<commit_message>
In a great state
</commit_message>
<xml_diff>
--- a/presentation/presentation-v4-gradient-noir.pptx
+++ b/presentation/presentation-v4-gradient-noir.pptx
@@ -3354,8 +3354,8 @@
         </p:nvSpPr>
         <p:spPr>
           <a:xfrm>
-            <a:off x="1371600" y="2286000"/>
-            <a:ext cx="9601200" cy="2286000"/>
+            <a:off x="0" y="2286000"/>
+            <a:ext cx="12191695" cy="2286000"/>
           </a:xfrm>
           <a:prstGeom prst="rect">
             <a:avLst/>
@@ -3515,7 +3515,7 @@
         </p:nvSpPr>
         <p:spPr>
           <a:xfrm>
-            <a:off x="2606040" y="2971800"/>
+            <a:off x="2606040" y="3017520"/>
             <a:ext cx="365760" cy="548640"/>
           </a:xfrm>
           <a:prstGeom prst="rect">
@@ -3606,7 +3606,7 @@
         </p:nvSpPr>
         <p:spPr>
           <a:xfrm>
-            <a:off x="4892040" y="2971800"/>
+            <a:off x="4892040" y="3017520"/>
             <a:ext cx="365760" cy="548640"/>
           </a:xfrm>
           <a:prstGeom prst="rect">
@@ -3697,7 +3697,7 @@
         </p:nvSpPr>
         <p:spPr>
           <a:xfrm>
-            <a:off x="7178040" y="2971800"/>
+            <a:off x="7178040" y="3017520"/>
             <a:ext cx="365760" cy="548640"/>
           </a:xfrm>
           <a:prstGeom prst="rect">
@@ -3788,7 +3788,7 @@
         </p:nvSpPr>
         <p:spPr>
           <a:xfrm>
-            <a:off x="9464040" y="2971800"/>
+            <a:off x="9464040" y="3017520"/>
             <a:ext cx="365760" cy="548640"/>
           </a:xfrm>
           <a:prstGeom prst="rect">
@@ -3922,7 +3922,7 @@
         </p:nvSpPr>
         <p:spPr>
           <a:xfrm>
-            <a:off x="1638605" y="3840480"/>
+            <a:off x="10782605" y="3840480"/>
             <a:ext cx="13716" cy="288036"/>
           </a:xfrm>
           <a:prstGeom prst="rect">
@@ -3965,7 +3965,7 @@
         </p:nvSpPr>
         <p:spPr>
           <a:xfrm>
-            <a:off x="10782605" y="3840480"/>
+            <a:off x="1638605" y="3840480"/>
             <a:ext cx="13716" cy="288036"/>
           </a:xfrm>
           <a:prstGeom prst="rect">
@@ -4008,8 +4008,8 @@
         </p:nvSpPr>
         <p:spPr>
           <a:xfrm>
-            <a:off x="4114800" y="4206240"/>
-            <a:ext cx="4114800" cy="457200"/>
+            <a:off x="1417320" y="3703320"/>
+            <a:ext cx="457200" cy="365760"/>
           </a:xfrm>
           <a:prstGeom prst="rect">
             <a:avLst/>
@@ -4025,20 +4025,56 @@
             <a:pPr algn="ctr">
               <a:defRPr sz="1400" b="0" i="0">
                 <a:solidFill>
+                  <a:srgbClr val="D4D0C8"/>
+                </a:solidFill>
+                <a:latin typeface="Segoe UI"/>
+              </a:defRPr>
+            </a:pPr>
+            <a:r>
+              <a:t>▲</a:t>
+            </a:r>
+          </a:p>
+        </p:txBody>
+      </p:sp>
+      <p:sp>
+        <p:nvSpPr>
+          <p:cNvPr id="16" name="TextBox 15"/>
+          <p:cNvSpPr txBox="1"/>
+          <p:nvPr/>
+        </p:nvSpPr>
+        <p:spPr>
+          <a:xfrm>
+            <a:off x="4114800" y="4206240"/>
+            <a:ext cx="4114800" cy="457200"/>
+          </a:xfrm>
+          <a:prstGeom prst="rect">
+            <a:avLst/>
+          </a:prstGeom>
+          <a:noFill/>
+        </p:spPr>
+        <p:txBody>
+          <a:bodyPr wrap="square">
+            <a:spAutoFit/>
+          </a:bodyPr>
+          <a:lstStyle/>
+          <a:p>
+            <a:pPr algn="ctr">
+              <a:defRPr sz="1400" b="0" i="0">
+                <a:solidFill>
                   <a:srgbClr val="6B7280"/>
                 </a:solidFill>
                 <a:latin typeface="Segoe UI"/>
               </a:defRPr>
             </a:pPr>
             <a:r>
-              <a:t>Continuous feedback loop</a:t>
-            </a:r>
-          </a:p>
-        </p:txBody>
-      </p:sp>
-      <p:sp>
-        <p:nvSpPr>
-          <p:cNvPr id="16" name="TextBox 15"/>
+              <a:t>Continuous feedback</a:t>
+            </a:r>
+          </a:p>
+        </p:txBody>
+      </p:sp>
+      <p:sp>
+        <p:nvSpPr>
+          <p:cNvPr id="17" name="TextBox 16"/>
           <p:cNvSpPr txBox="1"/>
           <p:nvPr/>
         </p:nvSpPr>
@@ -4383,42 +4419,6 @@
           </a:p>
         </p:txBody>
       </p:sp>
-      <p:sp>
-        <p:nvSpPr>
-          <p:cNvPr id="8" name="TextBox 7"/>
-          <p:cNvSpPr txBox="1"/>
-          <p:nvPr/>
-        </p:nvSpPr>
-        <p:spPr>
-          <a:xfrm>
-            <a:off x="1097280" y="5852160"/>
-            <a:ext cx="10058400" cy="548640"/>
-          </a:xfrm>
-          <a:prstGeom prst="rect">
-            <a:avLst/>
-          </a:prstGeom>
-          <a:noFill/>
-        </p:spPr>
-        <p:txBody>
-          <a:bodyPr wrap="square">
-            <a:spAutoFit/>
-          </a:bodyPr>
-          <a:lstStyle/>
-          <a:p>
-            <a:pPr algn="l">
-              <a:defRPr sz="1800" b="0" i="1">
-                <a:solidFill>
-                  <a:srgbClr val="E8E4D9"/>
-                </a:solidFill>
-                <a:latin typeface="Segoe UI"/>
-              </a:defRPr>
-            </a:pPr>
-            <a:r>
-              <a:t>Everything below the top layer already exists.</a:t>
-            </a:r>
-          </a:p>
-        </p:txBody>
-      </p:sp>
     </p:spTree>
   </p:cSld>
   <p:clrMapOvr>
@@ -4932,7 +4932,7 @@
         </p:nvSpPr>
         <p:spPr>
           <a:xfrm>
-            <a:off x="1097280" y="2011680"/>
+            <a:off x="929487" y="2011680"/>
             <a:ext cx="3200400" cy="1828800"/>
           </a:xfrm>
           <a:prstGeom prst="roundRect">
@@ -4987,7 +4987,7 @@
         </p:nvSpPr>
         <p:spPr>
           <a:xfrm>
-            <a:off x="1097280" y="4023360"/>
+            <a:off x="929487" y="4023360"/>
             <a:ext cx="3200400" cy="548640"/>
           </a:xfrm>
           <a:prstGeom prst="rect">
@@ -5023,8 +5023,8 @@
         </p:nvSpPr>
         <p:spPr>
           <a:xfrm>
-            <a:off x="4206240" y="2468880"/>
-            <a:ext cx="640080" cy="731520"/>
+            <a:off x="4129887" y="2560320"/>
+            <a:ext cx="365760" cy="731520"/>
           </a:xfrm>
           <a:prstGeom prst="rect">
             <a:avLst/>
@@ -5059,7 +5059,7 @@
         </p:nvSpPr>
         <p:spPr>
           <a:xfrm>
-            <a:off x="4754880" y="2011680"/>
+            <a:off x="4495647" y="2011680"/>
             <a:ext cx="3200400" cy="1828800"/>
           </a:xfrm>
           <a:prstGeom prst="roundRect">
@@ -5114,7 +5114,7 @@
         </p:nvSpPr>
         <p:spPr>
           <a:xfrm>
-            <a:off x="4754880" y="4023360"/>
+            <a:off x="4495647" y="4023360"/>
             <a:ext cx="3200400" cy="548640"/>
           </a:xfrm>
           <a:prstGeom prst="rect">
@@ -5150,8 +5150,8 @@
         </p:nvSpPr>
         <p:spPr>
           <a:xfrm>
-            <a:off x="7863840" y="2468880"/>
-            <a:ext cx="640080" cy="731520"/>
+            <a:off x="7696047" y="2560320"/>
+            <a:ext cx="365760" cy="731520"/>
           </a:xfrm>
           <a:prstGeom prst="rect">
             <a:avLst/>
@@ -5186,7 +5186,7 @@
         </p:nvSpPr>
         <p:spPr>
           <a:xfrm>
-            <a:off x="8412480" y="2011680"/>
+            <a:off x="8061807" y="2011680"/>
             <a:ext cx="3200400" cy="1828800"/>
           </a:xfrm>
           <a:prstGeom prst="roundRect">
@@ -5241,7 +5241,7 @@
         </p:nvSpPr>
         <p:spPr>
           <a:xfrm>
-            <a:off x="8412480" y="4023360"/>
+            <a:off x="8061807" y="4023360"/>
             <a:ext cx="3200400" cy="548640"/>
           </a:xfrm>
           <a:prstGeom prst="rect">
@@ -5387,7 +5387,7 @@
         </p:nvSpPr>
         <p:spPr>
           <a:xfrm>
-            <a:off x="914400" y="1645920"/>
+            <a:off x="838047" y="1645920"/>
             <a:ext cx="3291840" cy="1188720"/>
           </a:xfrm>
           <a:prstGeom prst="roundRect">
@@ -5442,7 +5442,7 @@
         </p:nvSpPr>
         <p:spPr>
           <a:xfrm>
-            <a:off x="1188720" y="3108960"/>
+            <a:off x="1112367" y="3108960"/>
             <a:ext cx="2743200" cy="1828800"/>
           </a:xfrm>
           <a:prstGeom prst="rect">
@@ -5486,7 +5486,7 @@
         </p:nvSpPr>
         <p:spPr>
           <a:xfrm>
-            <a:off x="4663440" y="1645920"/>
+            <a:off x="4449927" y="1645920"/>
             <a:ext cx="3291840" cy="1188720"/>
           </a:xfrm>
           <a:prstGeom prst="roundRect">
@@ -5541,7 +5541,7 @@
         </p:nvSpPr>
         <p:spPr>
           <a:xfrm>
-            <a:off x="4937760" y="3108960"/>
+            <a:off x="4724247" y="3108960"/>
             <a:ext cx="2743200" cy="1828800"/>
           </a:xfrm>
           <a:prstGeom prst="rect">
@@ -5585,7 +5585,7 @@
         </p:nvSpPr>
         <p:spPr>
           <a:xfrm>
-            <a:off x="8412480" y="1645920"/>
+            <a:off x="8061807" y="1645920"/>
             <a:ext cx="3291840" cy="1188720"/>
           </a:xfrm>
           <a:prstGeom prst="roundRect">
@@ -5640,7 +5640,7 @@
         </p:nvSpPr>
         <p:spPr>
           <a:xfrm>
-            <a:off x="8686800" y="3108960"/>
+            <a:off x="8336127" y="3108960"/>
             <a:ext cx="2743200" cy="1828800"/>
           </a:xfrm>
           <a:prstGeom prst="rect">
@@ -6316,61 +6316,30 @@
           </a:p>
         </p:txBody>
       </p:sp>
-      <p:sp>
-        <p:nvSpPr>
-          <p:cNvPr id="3" name="Rounded Rectangle 2"/>
-          <p:cNvSpPr/>
-          <p:nvPr/>
-        </p:nvSpPr>
-        <p:spPr>
-          <a:xfrm>
-            <a:off x="4114800" y="2286000"/>
-            <a:ext cx="3931920" cy="3200400"/>
-          </a:xfrm>
-          <a:prstGeom prst="roundRect">
-            <a:avLst/>
-          </a:prstGeom>
-          <a:solidFill>
-            <a:srgbClr val="151D30"/>
-          </a:solidFill>
-          <a:ln w="19050">
-            <a:solidFill>
-              <a:srgbClr val="D4D0C8"/>
-            </a:solidFill>
-          </a:ln>
-        </p:spPr>
-        <p:style>
-          <a:lnRef idx="1">
-            <a:schemeClr val="accent1"/>
-          </a:lnRef>
-          <a:fillRef idx="3">
-            <a:schemeClr val="accent1"/>
-          </a:fillRef>
-          <a:effectRef idx="2">
-            <a:schemeClr val="accent1"/>
-          </a:effectRef>
-          <a:fontRef idx="minor">
-            <a:schemeClr val="lt1"/>
-          </a:fontRef>
-        </p:style>
-        <p:txBody>
-          <a:bodyPr rtlCol="0" anchor="ctr" wrap="square"/>
-          <a:lstStyle/>
-          <a:p>
-            <a:pPr algn="ctr">
-              <a:defRPr sz="2400" b="0">
-                <a:solidFill>
-                  <a:srgbClr val="6B7280"/>
-                </a:solidFill>
-                <a:latin typeface="Segoe UI"/>
-              </a:defRPr>
-            </a:pPr>
-            <a:r>
-              <a:t>[ QR Code ]</a:t>
-            </a:r>
-          </a:p>
-        </p:txBody>
-      </p:sp>
+      <p:pic>
+        <p:nvPicPr>
+          <p:cNvPr id="3" name="Picture 2" descr="qr-demo.png"/>
+          <p:cNvPicPr>
+            <a:picLocks noChangeAspect="1"/>
+          </p:cNvPicPr>
+          <p:nvPr/>
+        </p:nvPicPr>
+        <p:blipFill>
+          <a:blip r:embed="rId2"/>
+          <a:stretch>
+            <a:fillRect/>
+          </a:stretch>
+        </p:blipFill>
+        <p:spPr>
+          <a:xfrm>
+            <a:off x="4297680" y="2286000"/>
+            <a:ext cx="3566160" cy="3200400"/>
+          </a:xfrm>
+          <a:prstGeom prst="rect">
+            <a:avLst/>
+          </a:prstGeom>
+        </p:spPr>
+      </p:pic>
       <p:sp>
         <p:nvSpPr>
           <p:cNvPr id="4" name="Rounded Rectangle 3"/>
@@ -6532,6 +6501,42 @@
             </a:pPr>
             <a:r>
               <a:t>ADAS</a:t>
+            </a:r>
+          </a:p>
+        </p:txBody>
+      </p:sp>
+      <p:sp>
+        <p:nvSpPr>
+          <p:cNvPr id="7" name="TextBox 6"/>
+          <p:cNvSpPr txBox="1"/>
+          <p:nvPr/>
+        </p:nvSpPr>
+        <p:spPr>
+          <a:xfrm>
+            <a:off x="0" y="6355080"/>
+            <a:ext cx="12191695" cy="365760"/>
+          </a:xfrm>
+          <a:prstGeom prst="rect">
+            <a:avLst/>
+          </a:prstGeom>
+          <a:noFill/>
+        </p:spPr>
+        <p:txBody>
+          <a:bodyPr wrap="square">
+            <a:spAutoFit/>
+          </a:bodyPr>
+          <a:lstStyle/>
+          <a:p>
+            <a:pPr algn="ctr">
+              <a:defRPr sz="1400" b="0" i="0">
+                <a:solidFill>
+                  <a:srgbClr val="6B7280"/>
+                </a:solidFill>
+                <a:latin typeface="Segoe UI"/>
+              </a:defRPr>
+            </a:pPr>
+            <a:r>
+              <a:t>tonypdemo.it.com</a:t>
             </a:r>
           </a:p>
         </p:txBody>
@@ -6662,7 +6667,7 @@
         <p:spPr>
           <a:xfrm>
             <a:off x="1371600" y="3657600"/>
-            <a:ext cx="9144000" cy="914400"/>
+            <a:ext cx="5486400" cy="914400"/>
           </a:xfrm>
           <a:prstGeom prst="rect">
             <a:avLst/>
@@ -6698,7 +6703,7 @@
         <p:spPr>
           <a:xfrm>
             <a:off x="1371600" y="4480560"/>
-            <a:ext cx="9144000" cy="548640"/>
+            <a:ext cx="5486400" cy="548640"/>
           </a:xfrm>
           <a:prstGeom prst="rect">
             <a:avLst/>
@@ -6734,7 +6739,7 @@
         <p:spPr>
           <a:xfrm>
             <a:off x="1371600" y="5212080"/>
-            <a:ext cx="9144000" cy="457200"/>
+            <a:ext cx="5486400" cy="457200"/>
           </a:xfrm>
           <a:prstGeom prst="rect">
             <a:avLst/>
@@ -6756,7 +6761,7 @@
               </a:defRPr>
             </a:pPr>
             <a:r>
-              <a:t>anthonypoole.dev  ·  linkedin.com/in/anthonypoole</a:t>
+              <a:t>anthony50102.github.io  ·  linkedin.com/in/anthony-poole-079548206</a:t>
             </a:r>
           </a:p>
         </p:txBody>
@@ -6770,7 +6775,7 @@
         <p:spPr>
           <a:xfrm>
             <a:off x="1371600" y="5943600"/>
-            <a:ext cx="9144000" cy="457200"/>
+            <a:ext cx="5486400" cy="457200"/>
           </a:xfrm>
           <a:prstGeom prst="rect">
             <a:avLst/>
@@ -6793,6 +6798,66 @@
             </a:pPr>
             <a:r>
               <a:t>Thank you.</a:t>
+            </a:r>
+          </a:p>
+        </p:txBody>
+      </p:sp>
+      <p:pic>
+        <p:nvPicPr>
+          <p:cNvPr id="8" name="Picture 7" descr="qr-personal.png"/>
+          <p:cNvPicPr>
+            <a:picLocks noChangeAspect="1"/>
+          </p:cNvPicPr>
+          <p:nvPr/>
+        </p:nvPicPr>
+        <p:blipFill>
+          <a:blip r:embed="rId2"/>
+          <a:stretch>
+            <a:fillRect/>
+          </a:stretch>
+        </p:blipFill>
+        <p:spPr>
+          <a:xfrm>
+            <a:off x="8869680" y="3657600"/>
+            <a:ext cx="2194560" cy="2194560"/>
+          </a:xfrm>
+          <a:prstGeom prst="rect">
+            <a:avLst/>
+          </a:prstGeom>
+        </p:spPr>
+      </p:pic>
+      <p:sp>
+        <p:nvSpPr>
+          <p:cNvPr id="9" name="TextBox 8"/>
+          <p:cNvSpPr txBox="1"/>
+          <p:nvPr/>
+        </p:nvSpPr>
+        <p:spPr>
+          <a:xfrm>
+            <a:off x="8686800" y="5897880"/>
+            <a:ext cx="2560320" cy="365760"/>
+          </a:xfrm>
+          <a:prstGeom prst="rect">
+            <a:avLst/>
+          </a:prstGeom>
+          <a:noFill/>
+        </p:spPr>
+        <p:txBody>
+          <a:bodyPr wrap="square">
+            <a:spAutoFit/>
+          </a:bodyPr>
+          <a:lstStyle/>
+          <a:p>
+            <a:pPr algn="ctr">
+              <a:defRPr sz="1200" b="0" i="0">
+                <a:solidFill>
+                  <a:srgbClr val="6B7280"/>
+                </a:solidFill>
+                <a:latin typeface="Segoe UI"/>
+              </a:defRPr>
+            </a:pPr>
+            <a:r>
+              <a:t>anthony50102.github.io</a:t>
             </a:r>
           </a:p>
         </p:txBody>
@@ -6839,8 +6904,8 @@
         </p:nvSpPr>
         <p:spPr>
           <a:xfrm>
-            <a:off x="1371600" y="2286000"/>
-            <a:ext cx="9144000" cy="2743200"/>
+            <a:off x="1097280" y="457200"/>
+            <a:ext cx="4572000" cy="457200"/>
           </a:xfrm>
           <a:prstGeom prst="rect">
             <a:avLst/>
@@ -6854,7 +6919,102 @@
           <a:lstStyle/>
           <a:p>
             <a:pPr algn="l">
-              <a:defRPr sz="4200" b="1" i="0">
+              <a:defRPr sz="1400" b="0" i="0">
+                <a:solidFill>
+                  <a:srgbClr val="4B5563"/>
+                </a:solidFill>
+                <a:latin typeface="Segoe UI"/>
+              </a:defRPr>
+            </a:pPr>
+            <a:r>
+              <a:t>The Foundation</a:t>
+            </a:r>
+          </a:p>
+        </p:txBody>
+      </p:sp>
+      <p:sp>
+        <p:nvSpPr>
+          <p:cNvPr id="3" name="Rounded Rectangle 2"/>
+          <p:cNvSpPr/>
+          <p:nvPr/>
+        </p:nvSpPr>
+        <p:spPr>
+          <a:xfrm>
+            <a:off x="731520" y="1645920"/>
+            <a:ext cx="4389120" cy="3657600"/>
+          </a:xfrm>
+          <a:prstGeom prst="roundRect">
+            <a:avLst/>
+          </a:prstGeom>
+          <a:solidFill>
+            <a:srgbClr val="151D30"/>
+          </a:solidFill>
+          <a:ln w="19050">
+            <a:solidFill>
+              <a:srgbClr val="D4D0C8"/>
+            </a:solidFill>
+          </a:ln>
+        </p:spPr>
+        <p:style>
+          <a:lnRef idx="1">
+            <a:schemeClr val="accent1"/>
+          </a:lnRef>
+          <a:fillRef idx="3">
+            <a:schemeClr val="accent1"/>
+          </a:fillRef>
+          <a:effectRef idx="2">
+            <a:schemeClr val="accent1"/>
+          </a:effectRef>
+          <a:fontRef idx="minor">
+            <a:schemeClr val="lt1"/>
+          </a:fontRef>
+        </p:style>
+        <p:txBody>
+          <a:bodyPr rtlCol="0" anchor="ctr" wrap="square"/>
+          <a:lstStyle/>
+          <a:p>
+            <a:pPr algn="ctr">
+              <a:defRPr sz="3200" b="1">
+                <a:solidFill>
+                  <a:srgbClr val="F5F5F0"/>
+                </a:solidFill>
+                <a:latin typeface="Segoe UI"/>
+              </a:defRPr>
+            </a:pPr>
+            <a:r>
+              <a:t>Physical</a:t>
+            </a:r>
+            <a:br/>
+            <a:r>
+              <a:t>System</a:t>
+            </a:r>
+          </a:p>
+        </p:txBody>
+      </p:sp>
+      <p:sp>
+        <p:nvSpPr>
+          <p:cNvPr id="4" name="TextBox 3"/>
+          <p:cNvSpPr txBox="1"/>
+          <p:nvPr/>
+        </p:nvSpPr>
+        <p:spPr>
+          <a:xfrm>
+            <a:off x="5212080" y="2011680"/>
+            <a:ext cx="1828800" cy="914400"/>
+          </a:xfrm>
+          <a:prstGeom prst="rect">
+            <a:avLst/>
+          </a:prstGeom>
+          <a:noFill/>
+        </p:spPr>
+        <p:txBody>
+          <a:bodyPr wrap="square">
+            <a:spAutoFit/>
+          </a:bodyPr>
+          <a:lstStyle/>
+          <a:p>
+            <a:pPr algn="ctr">
+              <a:defRPr sz="4800" b="0" i="0">
                 <a:solidFill>
                   <a:srgbClr val="E8E4D9"/>
                 </a:solidFill>
@@ -6862,15 +7022,210 @@
               </a:defRPr>
             </a:pPr>
             <a:r>
-              <a:t>Your twins can see everything.</a:t>
+              <a:t>→</a:t>
+            </a:r>
+          </a:p>
+        </p:txBody>
+      </p:sp>
+      <p:sp>
+        <p:nvSpPr>
+          <p:cNvPr id="5" name="TextBox 4"/>
+          <p:cNvSpPr txBox="1"/>
+          <p:nvPr/>
+        </p:nvSpPr>
+        <p:spPr>
+          <a:xfrm>
+            <a:off x="5212080" y="2743200"/>
+            <a:ext cx="1828800" cy="457200"/>
+          </a:xfrm>
+          <a:prstGeom prst="rect">
+            <a:avLst/>
+          </a:prstGeom>
+          <a:noFill/>
+        </p:spPr>
+        <p:txBody>
+          <a:bodyPr wrap="square">
+            <a:spAutoFit/>
+          </a:bodyPr>
+          <a:lstStyle/>
+          <a:p>
+            <a:pPr algn="ctr">
+              <a:defRPr sz="1600" b="0" i="0">
+                <a:solidFill>
+                  <a:srgbClr val="6B7280"/>
+                </a:solidFill>
+                <a:latin typeface="Segoe UI"/>
+              </a:defRPr>
+            </a:pPr>
+            <a:r>
+              <a:t>Sensors &amp; Data</a:t>
+            </a:r>
+          </a:p>
+        </p:txBody>
+      </p:sp>
+      <p:sp>
+        <p:nvSpPr>
+          <p:cNvPr id="6" name="TextBox 5"/>
+          <p:cNvSpPr txBox="1"/>
+          <p:nvPr/>
+        </p:nvSpPr>
+        <p:spPr>
+          <a:xfrm>
+            <a:off x="5212080" y="3657600"/>
+            <a:ext cx="1828800" cy="914400"/>
+          </a:xfrm>
+          <a:prstGeom prst="rect">
+            <a:avLst/>
+          </a:prstGeom>
+          <a:noFill/>
+        </p:spPr>
+        <p:txBody>
+          <a:bodyPr wrap="square">
+            <a:spAutoFit/>
+          </a:bodyPr>
+          <a:lstStyle/>
+          <a:p>
+            <a:pPr algn="ctr">
+              <a:defRPr sz="4800" b="0" i="0">
+                <a:solidFill>
+                  <a:srgbClr val="E8E4D9"/>
+                </a:solidFill>
+                <a:latin typeface="Segoe UI"/>
+              </a:defRPr>
+            </a:pPr>
+            <a:r>
+              <a:t>←</a:t>
+            </a:r>
+          </a:p>
+        </p:txBody>
+      </p:sp>
+      <p:sp>
+        <p:nvSpPr>
+          <p:cNvPr id="7" name="TextBox 6"/>
+          <p:cNvSpPr txBox="1"/>
+          <p:nvPr/>
+        </p:nvSpPr>
+        <p:spPr>
+          <a:xfrm>
+            <a:off x="5212080" y="4389120"/>
+            <a:ext cx="1828800" cy="457200"/>
+          </a:xfrm>
+          <a:prstGeom prst="rect">
+            <a:avLst/>
+          </a:prstGeom>
+          <a:noFill/>
+        </p:spPr>
+        <p:txBody>
+          <a:bodyPr wrap="square">
+            <a:spAutoFit/>
+          </a:bodyPr>
+          <a:lstStyle/>
+          <a:p>
+            <a:pPr algn="ctr">
+              <a:defRPr sz="1600" b="0" i="0">
+                <a:solidFill>
+                  <a:srgbClr val="6B7280"/>
+                </a:solidFill>
+                <a:latin typeface="Segoe UI"/>
+              </a:defRPr>
+            </a:pPr>
+            <a:r>
+              <a:t>Simulation</a:t>
+            </a:r>
+          </a:p>
+        </p:txBody>
+      </p:sp>
+      <p:sp>
+        <p:nvSpPr>
+          <p:cNvPr id="8" name="Rounded Rectangle 7"/>
+          <p:cNvSpPr/>
+          <p:nvPr/>
+        </p:nvSpPr>
+        <p:spPr>
+          <a:xfrm>
+            <a:off x="7040880" y="1645920"/>
+            <a:ext cx="4389120" cy="3657600"/>
+          </a:xfrm>
+          <a:prstGeom prst="roundRect">
+            <a:avLst/>
+          </a:prstGeom>
+          <a:solidFill>
+            <a:srgbClr val="151D30"/>
+          </a:solidFill>
+          <a:ln w="19050">
+            <a:solidFill>
+              <a:srgbClr val="D4D0C8"/>
+            </a:solidFill>
+          </a:ln>
+        </p:spPr>
+        <p:style>
+          <a:lnRef idx="1">
+            <a:schemeClr val="accent1"/>
+          </a:lnRef>
+          <a:fillRef idx="3">
+            <a:schemeClr val="accent1"/>
+          </a:fillRef>
+          <a:effectRef idx="2">
+            <a:schemeClr val="accent1"/>
+          </a:effectRef>
+          <a:fontRef idx="minor">
+            <a:schemeClr val="lt1"/>
+          </a:fontRef>
+        </p:style>
+        <p:txBody>
+          <a:bodyPr rtlCol="0" anchor="ctr" wrap="square"/>
+          <a:lstStyle/>
+          <a:p>
+            <a:pPr algn="ctr">
+              <a:defRPr sz="3200" b="1">
+                <a:solidFill>
+                  <a:srgbClr val="F5F5F0"/>
+                </a:solidFill>
+                <a:latin typeface="Segoe UI"/>
+              </a:defRPr>
+            </a:pPr>
+            <a:r>
+              <a:t>Digital</a:t>
             </a:r>
             <a:br/>
             <a:r>
-              <a:t>They can't do anything</a:t>
-            </a:r>
-            <a:br/>
-            <a:r>
-              <a:t>about what they see.</a:t>
+              <a:t>Twin</a:t>
+            </a:r>
+          </a:p>
+        </p:txBody>
+      </p:sp>
+      <p:sp>
+        <p:nvSpPr>
+          <p:cNvPr id="9" name="TextBox 8"/>
+          <p:cNvSpPr txBox="1"/>
+          <p:nvPr/>
+        </p:nvSpPr>
+        <p:spPr>
+          <a:xfrm>
+            <a:off x="1097280" y="5669280"/>
+            <a:ext cx="10058400" cy="731520"/>
+          </a:xfrm>
+          <a:prstGeom prst="rect">
+            <a:avLst/>
+          </a:prstGeom>
+          <a:noFill/>
+        </p:spPr>
+        <p:txBody>
+          <a:bodyPr wrap="square">
+            <a:spAutoFit/>
+          </a:bodyPr>
+          <a:lstStyle/>
+          <a:p>
+            <a:pPr algn="l">
+              <a:defRPr sz="2000" b="0" i="0">
+                <a:solidFill>
+                  <a:srgbClr val="6B7280"/>
+                </a:solidFill>
+                <a:latin typeface="Segoe UI"/>
+              </a:defRPr>
+            </a:pPr>
+            <a:r>
+              <a:t>A virtual model, continuously synced with a physical system.</a:t>
             </a:r>
           </a:p>
         </p:txBody>
@@ -6917,8 +7272,8 @@
         </p:nvSpPr>
         <p:spPr>
           <a:xfrm>
-            <a:off x="1097280" y="457200"/>
-            <a:ext cx="4572000" cy="457200"/>
+            <a:off x="1097280" y="1188720"/>
+            <a:ext cx="3200400" cy="914400"/>
           </a:xfrm>
           <a:prstGeom prst="rect">
             <a:avLst/>
@@ -6932,40 +7287,230 @@
           <a:lstStyle/>
           <a:p>
             <a:pPr algn="l">
-              <a:defRPr sz="1400" b="0" i="0">
-                <a:solidFill>
-                  <a:srgbClr val="4B5563"/>
-                </a:solidFill>
-                <a:latin typeface="Segoe UI"/>
-              </a:defRPr>
-            </a:pPr>
-            <a:r>
-              <a:t>The Foundation</a:t>
-            </a:r>
-          </a:p>
-        </p:txBody>
-      </p:sp>
-      <p:sp>
-        <p:nvSpPr>
-          <p:cNvPr id="3" name="Rounded Rectangle 2"/>
+              <a:defRPr sz="4800" b="1" i="0">
+                <a:solidFill>
+                  <a:srgbClr val="F5F5F0"/>
+                </a:solidFill>
+                <a:latin typeface="Segoe UI"/>
+              </a:defRPr>
+            </a:pPr>
+            <a:r>
+              <a:t>$22K / min</a:t>
+            </a:r>
+          </a:p>
+        </p:txBody>
+      </p:sp>
+      <p:sp>
+        <p:nvSpPr>
+          <p:cNvPr id="3" name="TextBox 2"/>
+          <p:cNvSpPr txBox="1"/>
+          <p:nvPr/>
+        </p:nvSpPr>
+        <p:spPr>
+          <a:xfrm>
+            <a:off x="1097280" y="2194560"/>
+            <a:ext cx="3200400" cy="914400"/>
+          </a:xfrm>
+          <a:prstGeom prst="rect">
+            <a:avLst/>
+          </a:prstGeom>
+          <a:noFill/>
+        </p:spPr>
+        <p:txBody>
+          <a:bodyPr wrap="square">
+            <a:spAutoFit/>
+          </a:bodyPr>
+          <a:lstStyle/>
+          <a:p>
+            <a:pPr algn="l">
+              <a:defRPr sz="1600" b="0" i="0">
+                <a:solidFill>
+                  <a:srgbClr val="6B7280"/>
+                </a:solidFill>
+                <a:latin typeface="Segoe UI"/>
+              </a:defRPr>
+            </a:pPr>
+            <a:r>
+              <a:t>Automotive</a:t>
+            </a:r>
+            <a:br/>
+            <a:r>
+              <a:t>downtime</a:t>
+            </a:r>
+          </a:p>
+        </p:txBody>
+      </p:sp>
+      <p:sp>
+        <p:nvSpPr>
+          <p:cNvPr id="4" name="TextBox 3"/>
+          <p:cNvSpPr txBox="1"/>
+          <p:nvPr/>
+        </p:nvSpPr>
+        <p:spPr>
+          <a:xfrm>
+            <a:off x="4754880" y="1188720"/>
+            <a:ext cx="3200400" cy="914400"/>
+          </a:xfrm>
+          <a:prstGeom prst="rect">
+            <a:avLst/>
+          </a:prstGeom>
+          <a:noFill/>
+        </p:spPr>
+        <p:txBody>
+          <a:bodyPr wrap="square">
+            <a:spAutoFit/>
+          </a:bodyPr>
+          <a:lstStyle/>
+          <a:p>
+            <a:pPr algn="l">
+              <a:defRPr sz="4800" b="1" i="0">
+                <a:solidFill>
+                  <a:srgbClr val="F5F5F0"/>
+                </a:solidFill>
+                <a:latin typeface="Segoe UI"/>
+              </a:defRPr>
+            </a:pPr>
+            <a:r>
+              <a:t>$X / hour</a:t>
+            </a:r>
+          </a:p>
+        </p:txBody>
+      </p:sp>
+      <p:sp>
+        <p:nvSpPr>
+          <p:cNvPr id="5" name="TextBox 4"/>
+          <p:cNvSpPr txBox="1"/>
+          <p:nvPr/>
+        </p:nvSpPr>
+        <p:spPr>
+          <a:xfrm>
+            <a:off x="4754880" y="2194560"/>
+            <a:ext cx="3200400" cy="914400"/>
+          </a:xfrm>
+          <a:prstGeom prst="rect">
+            <a:avLst/>
+          </a:prstGeom>
+          <a:noFill/>
+        </p:spPr>
+        <p:txBody>
+          <a:bodyPr wrap="square">
+            <a:spAutoFit/>
+          </a:bodyPr>
+          <a:lstStyle/>
+          <a:p>
+            <a:pPr algn="l">
+              <a:defRPr sz="1600" b="0" i="0">
+                <a:solidFill>
+                  <a:srgbClr val="6B7280"/>
+                </a:solidFill>
+                <a:latin typeface="Segoe UI"/>
+              </a:defRPr>
+            </a:pPr>
+            <a:r>
+              <a:t>Semiconductor</a:t>
+            </a:r>
+            <a:br/>
+            <a:r>
+              <a:t>fab downtime</a:t>
+            </a:r>
+          </a:p>
+        </p:txBody>
+      </p:sp>
+      <p:sp>
+        <p:nvSpPr>
+          <p:cNvPr id="6" name="TextBox 5"/>
+          <p:cNvSpPr txBox="1"/>
+          <p:nvPr/>
+        </p:nvSpPr>
+        <p:spPr>
+          <a:xfrm>
+            <a:off x="8412480" y="1188720"/>
+            <a:ext cx="3200400" cy="914400"/>
+          </a:xfrm>
+          <a:prstGeom prst="rect">
+            <a:avLst/>
+          </a:prstGeom>
+          <a:noFill/>
+        </p:spPr>
+        <p:txBody>
+          <a:bodyPr wrap="square">
+            <a:spAutoFit/>
+          </a:bodyPr>
+          <a:lstStyle/>
+          <a:p>
+            <a:pPr algn="l">
+              <a:defRPr sz="4800" b="1" i="0">
+                <a:solidFill>
+                  <a:srgbClr val="F5F5F0"/>
+                </a:solidFill>
+                <a:latin typeface="Segoe UI"/>
+              </a:defRPr>
+            </a:pPr>
+            <a:r>
+              <a:t>$X / event</a:t>
+            </a:r>
+          </a:p>
+        </p:txBody>
+      </p:sp>
+      <p:sp>
+        <p:nvSpPr>
+          <p:cNvPr id="7" name="TextBox 6"/>
+          <p:cNvSpPr txBox="1"/>
+          <p:nvPr/>
+        </p:nvSpPr>
+        <p:spPr>
+          <a:xfrm>
+            <a:off x="8412480" y="2194560"/>
+            <a:ext cx="3200400" cy="914400"/>
+          </a:xfrm>
+          <a:prstGeom prst="rect">
+            <a:avLst/>
+          </a:prstGeom>
+          <a:noFill/>
+        </p:spPr>
+        <p:txBody>
+          <a:bodyPr wrap="square">
+            <a:spAutoFit/>
+          </a:bodyPr>
+          <a:lstStyle/>
+          <a:p>
+            <a:pPr algn="l">
+              <a:defRPr sz="1600" b="0" i="0">
+                <a:solidFill>
+                  <a:srgbClr val="6B7280"/>
+                </a:solidFill>
+                <a:latin typeface="Segoe UI"/>
+              </a:defRPr>
+            </a:pPr>
+            <a:r>
+              <a:t>Energy grid</a:t>
+            </a:r>
+            <a:br/>
+            <a:r>
+              <a:t>outage cost</a:t>
+            </a:r>
+          </a:p>
+        </p:txBody>
+      </p:sp>
+      <p:sp>
+        <p:nvSpPr>
+          <p:cNvPr id="8" name="Rectangle 7"/>
           <p:cNvSpPr/>
           <p:nvPr/>
         </p:nvSpPr>
         <p:spPr>
           <a:xfrm>
-            <a:off x="731520" y="1645920"/>
-            <a:ext cx="4389120" cy="3657600"/>
-          </a:xfrm>
-          <a:prstGeom prst="roundRect">
+            <a:off x="1097280" y="3657600"/>
+            <a:ext cx="1828800" cy="13716"/>
+          </a:xfrm>
+          <a:prstGeom prst="rect">
             <a:avLst/>
           </a:prstGeom>
           <a:solidFill>
-            <a:srgbClr val="151D30"/>
+            <a:srgbClr val="D4D0C8"/>
           </a:solidFill>
-          <a:ln w="19050">
-            <a:solidFill>
-              <a:srgbClr val="D4D0C8"/>
-            </a:solidFill>
+          <a:ln>
+            <a:noFill/>
           </a:ln>
         </p:spPr>
         <p:style>
@@ -6983,37 +7528,23 @@
           </a:fontRef>
         </p:style>
         <p:txBody>
-          <a:bodyPr rtlCol="0" anchor="ctr" wrap="square"/>
-          <a:lstStyle/>
-          <a:p>
-            <a:pPr algn="ctr">
-              <a:defRPr sz="3200" b="1">
-                <a:solidFill>
-                  <a:srgbClr val="F5F5F0"/>
-                </a:solidFill>
-                <a:latin typeface="Segoe UI"/>
-              </a:defRPr>
-            </a:pPr>
-            <a:r>
-              <a:t>Physical</a:t>
-            </a:r>
-            <a:br/>
-            <a:r>
-              <a:t>System</a:t>
-            </a:r>
-          </a:p>
-        </p:txBody>
-      </p:sp>
-      <p:sp>
-        <p:nvSpPr>
-          <p:cNvPr id="4" name="TextBox 3"/>
+          <a:bodyPr rtlCol="0" anchor="ctr"/>
+          <a:lstStyle/>
+          <a:p>
+            <a:pPr algn="ctr"/>
+          </a:p>
+        </p:txBody>
+      </p:sp>
+      <p:sp>
+        <p:nvSpPr>
+          <p:cNvPr id="9" name="TextBox 8"/>
           <p:cNvSpPr txBox="1"/>
           <p:nvPr/>
         </p:nvSpPr>
         <p:spPr>
           <a:xfrm>
-            <a:off x="5212080" y="2286000"/>
-            <a:ext cx="1828800" cy="914400"/>
+            <a:off x="1097280" y="4023360"/>
+            <a:ext cx="9601200" cy="1828800"/>
           </a:xfrm>
           <a:prstGeom prst="rect">
             <a:avLst/>
@@ -7026,8 +7557,8 @@
           </a:bodyPr>
           <a:lstStyle/>
           <a:p>
-            <a:pPr algn="ctr">
-              <a:defRPr sz="1800" b="0" i="0">
+            <a:pPr algn="l">
+              <a:defRPr sz="3000" b="1" i="0">
                 <a:solidFill>
                   <a:srgbClr val="E8E4D9"/>
                 </a:solidFill>
@@ -7035,138 +7566,11 @@
               </a:defRPr>
             </a:pPr>
             <a:r>
-              <a:t>Sensors &amp; Data  →</a:t>
-            </a:r>
-          </a:p>
-        </p:txBody>
-      </p:sp>
-      <p:sp>
-        <p:nvSpPr>
-          <p:cNvPr id="5" name="TextBox 4"/>
-          <p:cNvSpPr txBox="1"/>
-          <p:nvPr/>
-        </p:nvSpPr>
-        <p:spPr>
-          <a:xfrm>
-            <a:off x="5212080" y="3840480"/>
-            <a:ext cx="1828800" cy="914400"/>
-          </a:xfrm>
-          <a:prstGeom prst="rect">
-            <a:avLst/>
-          </a:prstGeom>
-          <a:noFill/>
-        </p:spPr>
-        <p:txBody>
-          <a:bodyPr wrap="square">
-            <a:spAutoFit/>
-          </a:bodyPr>
-          <a:lstStyle/>
-          <a:p>
-            <a:pPr algn="ctr">
-              <a:defRPr sz="1800" b="0" i="0">
-                <a:solidFill>
-                  <a:srgbClr val="E8E4D9"/>
-                </a:solidFill>
-                <a:latin typeface="Segoe UI"/>
-              </a:defRPr>
-            </a:pPr>
-            <a:r>
-              <a:t>←  Simulation</a:t>
-            </a:r>
-          </a:p>
-        </p:txBody>
-      </p:sp>
-      <p:sp>
-        <p:nvSpPr>
-          <p:cNvPr id="6" name="Rounded Rectangle 5"/>
-          <p:cNvSpPr/>
-          <p:nvPr/>
-        </p:nvSpPr>
-        <p:spPr>
-          <a:xfrm>
-            <a:off x="7040880" y="1645920"/>
-            <a:ext cx="4389120" cy="3657600"/>
-          </a:xfrm>
-          <a:prstGeom prst="roundRect">
-            <a:avLst/>
-          </a:prstGeom>
-          <a:solidFill>
-            <a:srgbClr val="151D30"/>
-          </a:solidFill>
-          <a:ln w="19050">
-            <a:solidFill>
-              <a:srgbClr val="D4D0C8"/>
-            </a:solidFill>
-          </a:ln>
-        </p:spPr>
-        <p:style>
-          <a:lnRef idx="1">
-            <a:schemeClr val="accent1"/>
-          </a:lnRef>
-          <a:fillRef idx="3">
-            <a:schemeClr val="accent1"/>
-          </a:fillRef>
-          <a:effectRef idx="2">
-            <a:schemeClr val="accent1"/>
-          </a:effectRef>
-          <a:fontRef idx="minor">
-            <a:schemeClr val="lt1"/>
-          </a:fontRef>
-        </p:style>
-        <p:txBody>
-          <a:bodyPr rtlCol="0" anchor="ctr" wrap="square"/>
-          <a:lstStyle/>
-          <a:p>
-            <a:pPr algn="ctr">
-              <a:defRPr sz="3200" b="1">
-                <a:solidFill>
-                  <a:srgbClr val="F5F5F0"/>
-                </a:solidFill>
-                <a:latin typeface="Segoe UI"/>
-              </a:defRPr>
-            </a:pPr>
-            <a:r>
-              <a:t>Digital</a:t>
+              <a:t>Your systems generate more data every hour</a:t>
             </a:r>
             <a:br/>
             <a:r>
-              <a:t>Twin</a:t>
-            </a:r>
-          </a:p>
-        </p:txBody>
-      </p:sp>
-      <p:sp>
-        <p:nvSpPr>
-          <p:cNvPr id="7" name="TextBox 6"/>
-          <p:cNvSpPr txBox="1"/>
-          <p:nvPr/>
-        </p:nvSpPr>
-        <p:spPr>
-          <a:xfrm>
-            <a:off x="1097280" y="5669280"/>
-            <a:ext cx="10058400" cy="731520"/>
-          </a:xfrm>
-          <a:prstGeom prst="rect">
-            <a:avLst/>
-          </a:prstGeom>
-          <a:noFill/>
-        </p:spPr>
-        <p:txBody>
-          <a:bodyPr wrap="square">
-            <a:spAutoFit/>
-          </a:bodyPr>
-          <a:lstStyle/>
-          <a:p>
-            <a:pPr algn="l">
-              <a:defRPr sz="2000" b="0" i="0">
-                <a:solidFill>
-                  <a:srgbClr val="6B7280"/>
-                </a:solidFill>
-                <a:latin typeface="Segoe UI"/>
-              </a:defRPr>
-            </a:pPr>
-            <a:r>
-              <a:t>A virtual model, continuously synced with a physical system.</a:t>
+              <a:t>than your teams can act on in a week.</a:t>
             </a:r>
           </a:p>
         </p:txBody>
@@ -7213,8 +7617,8 @@
         </p:nvSpPr>
         <p:spPr>
           <a:xfrm>
-            <a:off x="1097280" y="1188720"/>
-            <a:ext cx="3200400" cy="914400"/>
+            <a:off x="1097280" y="457200"/>
+            <a:ext cx="4572000" cy="457200"/>
           </a:xfrm>
           <a:prstGeom prst="rect">
             <a:avLst/>
@@ -7228,230 +7632,40 @@
           <a:lstStyle/>
           <a:p>
             <a:pPr algn="l">
-              <a:defRPr sz="4800" b="1" i="0">
-                <a:solidFill>
-                  <a:srgbClr val="F5F5F0"/>
-                </a:solidFill>
-                <a:latin typeface="Segoe UI"/>
-              </a:defRPr>
-            </a:pPr>
-            <a:r>
-              <a:t>$22K / min</a:t>
-            </a:r>
-          </a:p>
-        </p:txBody>
-      </p:sp>
-      <p:sp>
-        <p:nvSpPr>
-          <p:cNvPr id="3" name="TextBox 2"/>
-          <p:cNvSpPr txBox="1"/>
-          <p:nvPr/>
-        </p:nvSpPr>
-        <p:spPr>
-          <a:xfrm>
-            <a:off x="1097280" y="2194560"/>
-            <a:ext cx="3200400" cy="914400"/>
-          </a:xfrm>
-          <a:prstGeom prst="rect">
-            <a:avLst/>
-          </a:prstGeom>
-          <a:noFill/>
-        </p:spPr>
-        <p:txBody>
-          <a:bodyPr wrap="square">
-            <a:spAutoFit/>
-          </a:bodyPr>
-          <a:lstStyle/>
-          <a:p>
-            <a:pPr algn="l">
-              <a:defRPr sz="1600" b="0" i="0">
-                <a:solidFill>
-                  <a:srgbClr val="6B7280"/>
-                </a:solidFill>
-                <a:latin typeface="Segoe UI"/>
-              </a:defRPr>
-            </a:pPr>
-            <a:r>
-              <a:t>Automotive</a:t>
-            </a:r>
-            <a:br/>
-            <a:r>
-              <a:t>downtime</a:t>
-            </a:r>
-          </a:p>
-        </p:txBody>
-      </p:sp>
-      <p:sp>
-        <p:nvSpPr>
-          <p:cNvPr id="4" name="TextBox 3"/>
-          <p:cNvSpPr txBox="1"/>
-          <p:nvPr/>
-        </p:nvSpPr>
-        <p:spPr>
-          <a:xfrm>
-            <a:off x="4754880" y="1188720"/>
-            <a:ext cx="3200400" cy="914400"/>
-          </a:xfrm>
-          <a:prstGeom prst="rect">
-            <a:avLst/>
-          </a:prstGeom>
-          <a:noFill/>
-        </p:spPr>
-        <p:txBody>
-          <a:bodyPr wrap="square">
-            <a:spAutoFit/>
-          </a:bodyPr>
-          <a:lstStyle/>
-          <a:p>
-            <a:pPr algn="l">
-              <a:defRPr sz="4800" b="1" i="0">
-                <a:solidFill>
-                  <a:srgbClr val="F5F5F0"/>
-                </a:solidFill>
-                <a:latin typeface="Segoe UI"/>
-              </a:defRPr>
-            </a:pPr>
-            <a:r>
-              <a:t>$X / hour</a:t>
-            </a:r>
-          </a:p>
-        </p:txBody>
-      </p:sp>
-      <p:sp>
-        <p:nvSpPr>
-          <p:cNvPr id="5" name="TextBox 4"/>
-          <p:cNvSpPr txBox="1"/>
-          <p:nvPr/>
-        </p:nvSpPr>
-        <p:spPr>
-          <a:xfrm>
-            <a:off x="4754880" y="2194560"/>
-            <a:ext cx="3200400" cy="914400"/>
-          </a:xfrm>
-          <a:prstGeom prst="rect">
-            <a:avLst/>
-          </a:prstGeom>
-          <a:noFill/>
-        </p:spPr>
-        <p:txBody>
-          <a:bodyPr wrap="square">
-            <a:spAutoFit/>
-          </a:bodyPr>
-          <a:lstStyle/>
-          <a:p>
-            <a:pPr algn="l">
-              <a:defRPr sz="1600" b="0" i="0">
-                <a:solidFill>
-                  <a:srgbClr val="6B7280"/>
-                </a:solidFill>
-                <a:latin typeface="Segoe UI"/>
-              </a:defRPr>
-            </a:pPr>
-            <a:r>
-              <a:t>Semiconductor</a:t>
-            </a:r>
-            <a:br/>
-            <a:r>
-              <a:t>fab downtime</a:t>
-            </a:r>
-          </a:p>
-        </p:txBody>
-      </p:sp>
-      <p:sp>
-        <p:nvSpPr>
-          <p:cNvPr id="6" name="TextBox 5"/>
-          <p:cNvSpPr txBox="1"/>
-          <p:nvPr/>
-        </p:nvSpPr>
-        <p:spPr>
-          <a:xfrm>
-            <a:off x="8412480" y="1188720"/>
-            <a:ext cx="3200400" cy="914400"/>
-          </a:xfrm>
-          <a:prstGeom prst="rect">
-            <a:avLst/>
-          </a:prstGeom>
-          <a:noFill/>
-        </p:spPr>
-        <p:txBody>
-          <a:bodyPr wrap="square">
-            <a:spAutoFit/>
-          </a:bodyPr>
-          <a:lstStyle/>
-          <a:p>
-            <a:pPr algn="l">
-              <a:defRPr sz="4800" b="1" i="0">
-                <a:solidFill>
-                  <a:srgbClr val="F5F5F0"/>
-                </a:solidFill>
-                <a:latin typeface="Segoe UI"/>
-              </a:defRPr>
-            </a:pPr>
-            <a:r>
-              <a:t>$X / event</a:t>
-            </a:r>
-          </a:p>
-        </p:txBody>
-      </p:sp>
-      <p:sp>
-        <p:nvSpPr>
-          <p:cNvPr id="7" name="TextBox 6"/>
-          <p:cNvSpPr txBox="1"/>
-          <p:nvPr/>
-        </p:nvSpPr>
-        <p:spPr>
-          <a:xfrm>
-            <a:off x="8412480" y="2194560"/>
-            <a:ext cx="3200400" cy="914400"/>
-          </a:xfrm>
-          <a:prstGeom prst="rect">
-            <a:avLst/>
-          </a:prstGeom>
-          <a:noFill/>
-        </p:spPr>
-        <p:txBody>
-          <a:bodyPr wrap="square">
-            <a:spAutoFit/>
-          </a:bodyPr>
-          <a:lstStyle/>
-          <a:p>
-            <a:pPr algn="l">
-              <a:defRPr sz="1600" b="0" i="0">
-                <a:solidFill>
-                  <a:srgbClr val="6B7280"/>
-                </a:solidFill>
-                <a:latin typeface="Segoe UI"/>
-              </a:defRPr>
-            </a:pPr>
-            <a:r>
-              <a:t>Energy grid</a:t>
-            </a:r>
-            <a:br/>
-            <a:r>
-              <a:t>outage cost</a:t>
-            </a:r>
-          </a:p>
-        </p:txBody>
-      </p:sp>
-      <p:sp>
-        <p:nvSpPr>
-          <p:cNvPr id="8" name="Rectangle 7"/>
+              <a:defRPr sz="1400" b="0" i="0">
+                <a:solidFill>
+                  <a:srgbClr val="4B5563"/>
+                </a:solidFill>
+                <a:latin typeface="Segoe UI"/>
+              </a:defRPr>
+            </a:pPr>
+            <a:r>
+              <a:t>The Evolution</a:t>
+            </a:r>
+          </a:p>
+        </p:txBody>
+      </p:sp>
+      <p:sp>
+        <p:nvSpPr>
+          <p:cNvPr id="3" name="Rounded Rectangle 2"/>
           <p:cNvSpPr/>
           <p:nvPr/>
         </p:nvSpPr>
         <p:spPr>
           <a:xfrm>
-            <a:off x="1097280" y="3657600"/>
-            <a:ext cx="1828800" cy="13716"/>
-          </a:xfrm>
-          <a:prstGeom prst="rect">
+            <a:off x="746607" y="1645920"/>
+            <a:ext cx="2468880" cy="1188720"/>
+          </a:xfrm>
+          <a:prstGeom prst="roundRect">
             <a:avLst/>
           </a:prstGeom>
           <a:solidFill>
-            <a:srgbClr val="D4D0C8"/>
+            <a:srgbClr val="151D30"/>
           </a:solidFill>
-          <a:ln>
-            <a:noFill/>
+          <a:ln w="19050">
+            <a:solidFill>
+              <a:srgbClr val="4B5563"/>
+            </a:solidFill>
           </a:ln>
         </p:spPr>
         <p:style>
@@ -7469,23 +7683,33 @@
           </a:fontRef>
         </p:style>
         <p:txBody>
-          <a:bodyPr rtlCol="0" anchor="ctr"/>
-          <a:lstStyle/>
-          <a:p>
-            <a:pPr algn="ctr"/>
-          </a:p>
-        </p:txBody>
-      </p:sp>
-      <p:sp>
-        <p:nvSpPr>
-          <p:cNvPr id="9" name="TextBox 8"/>
+          <a:bodyPr rtlCol="0" anchor="ctr" wrap="square"/>
+          <a:lstStyle/>
+          <a:p>
+            <a:pPr algn="ctr">
+              <a:defRPr sz="2000" b="1">
+                <a:solidFill>
+                  <a:srgbClr val="F5F5F0"/>
+                </a:solidFill>
+                <a:latin typeface="Segoe UI"/>
+              </a:defRPr>
+            </a:pPr>
+            <a:r>
+              <a:t>Gen 1: Static</a:t>
+            </a:r>
+          </a:p>
+        </p:txBody>
+      </p:sp>
+      <p:sp>
+        <p:nvSpPr>
+          <p:cNvPr id="4" name="TextBox 3"/>
           <p:cNvSpPr txBox="1"/>
           <p:nvPr/>
         </p:nvSpPr>
         <p:spPr>
           <a:xfrm>
-            <a:off x="1097280" y="4023360"/>
-            <a:ext cx="9601200" cy="1828800"/>
+            <a:off x="746607" y="3017520"/>
+            <a:ext cx="2468880" cy="1097280"/>
           </a:xfrm>
           <a:prstGeom prst="rect">
             <a:avLst/>
@@ -7498,8 +7722,399 @@
           </a:bodyPr>
           <a:lstStyle/>
           <a:p>
+            <a:pPr algn="ctr">
+              <a:defRPr sz="1500" b="0" i="0">
+                <a:solidFill>
+                  <a:srgbClr val="6B7280"/>
+                </a:solidFill>
+                <a:latin typeface="Segoe UI"/>
+              </a:defRPr>
+            </a:pPr>
+            <a:r>
+              <a:t>"Here's what</a:t>
+            </a:r>
+            <a:br/>
+            <a:r>
+              <a:t>it looks like"</a:t>
+            </a:r>
+          </a:p>
+        </p:txBody>
+      </p:sp>
+      <p:sp>
+        <p:nvSpPr>
+          <p:cNvPr id="5" name="TextBox 4"/>
+          <p:cNvSpPr txBox="1"/>
+          <p:nvPr/>
+        </p:nvSpPr>
+        <p:spPr>
+          <a:xfrm>
+            <a:off x="3215487" y="1920240"/>
+            <a:ext cx="274320" cy="914400"/>
+          </a:xfrm>
+          <a:prstGeom prst="rect">
+            <a:avLst/>
+          </a:prstGeom>
+          <a:noFill/>
+        </p:spPr>
+        <p:txBody>
+          <a:bodyPr wrap="square">
+            <a:spAutoFit/>
+          </a:bodyPr>
+          <a:lstStyle/>
+          <a:p>
+            <a:pPr algn="ctr">
+              <a:defRPr sz="2400" b="0" i="0">
+                <a:solidFill>
+                  <a:srgbClr val="4B5563"/>
+                </a:solidFill>
+                <a:latin typeface="Segoe UI"/>
+              </a:defRPr>
+            </a:pPr>
+            <a:r>
+              <a:t>→</a:t>
+            </a:r>
+          </a:p>
+        </p:txBody>
+      </p:sp>
+      <p:sp>
+        <p:nvSpPr>
+          <p:cNvPr id="6" name="Rounded Rectangle 5"/>
+          <p:cNvSpPr/>
+          <p:nvPr/>
+        </p:nvSpPr>
+        <p:spPr>
+          <a:xfrm>
+            <a:off x="3489807" y="1645920"/>
+            <a:ext cx="2468880" cy="1188720"/>
+          </a:xfrm>
+          <a:prstGeom prst="roundRect">
+            <a:avLst/>
+          </a:prstGeom>
+          <a:solidFill>
+            <a:srgbClr val="151D30"/>
+          </a:solidFill>
+          <a:ln w="19050">
+            <a:solidFill>
+              <a:srgbClr val="4B5563"/>
+            </a:solidFill>
+          </a:ln>
+        </p:spPr>
+        <p:style>
+          <a:lnRef idx="1">
+            <a:schemeClr val="accent1"/>
+          </a:lnRef>
+          <a:fillRef idx="3">
+            <a:schemeClr val="accent1"/>
+          </a:fillRef>
+          <a:effectRef idx="2">
+            <a:schemeClr val="accent1"/>
+          </a:effectRef>
+          <a:fontRef idx="minor">
+            <a:schemeClr val="lt1"/>
+          </a:fontRef>
+        </p:style>
+        <p:txBody>
+          <a:bodyPr rtlCol="0" anchor="ctr" wrap="square"/>
+          <a:lstStyle/>
+          <a:p>
+            <a:pPr algn="ctr">
+              <a:defRPr sz="2000" b="1">
+                <a:solidFill>
+                  <a:srgbClr val="F5F5F0"/>
+                </a:solidFill>
+                <a:latin typeface="Segoe UI"/>
+              </a:defRPr>
+            </a:pPr>
+            <a:r>
+              <a:t>Gen 2: Reactive</a:t>
+            </a:r>
+          </a:p>
+        </p:txBody>
+      </p:sp>
+      <p:sp>
+        <p:nvSpPr>
+          <p:cNvPr id="7" name="TextBox 6"/>
+          <p:cNvSpPr txBox="1"/>
+          <p:nvPr/>
+        </p:nvSpPr>
+        <p:spPr>
+          <a:xfrm>
+            <a:off x="3489807" y="3017520"/>
+            <a:ext cx="2468880" cy="1097280"/>
+          </a:xfrm>
+          <a:prstGeom prst="rect">
+            <a:avLst/>
+          </a:prstGeom>
+          <a:noFill/>
+        </p:spPr>
+        <p:txBody>
+          <a:bodyPr wrap="square">
+            <a:spAutoFit/>
+          </a:bodyPr>
+          <a:lstStyle/>
+          <a:p>
+            <a:pPr algn="ctr">
+              <a:defRPr sz="1500" b="0" i="0">
+                <a:solidFill>
+                  <a:srgbClr val="6B7280"/>
+                </a:solidFill>
+                <a:latin typeface="Segoe UI"/>
+              </a:defRPr>
+            </a:pPr>
+            <a:r>
+              <a:t>"Something</a:t>
+            </a:r>
+            <a:br/>
+            <a:r>
+              <a:t>went wrong"</a:t>
+            </a:r>
+          </a:p>
+        </p:txBody>
+      </p:sp>
+      <p:sp>
+        <p:nvSpPr>
+          <p:cNvPr id="8" name="TextBox 7"/>
+          <p:cNvSpPr txBox="1"/>
+          <p:nvPr/>
+        </p:nvSpPr>
+        <p:spPr>
+          <a:xfrm>
+            <a:off x="5958687" y="1920240"/>
+            <a:ext cx="274320" cy="914400"/>
+          </a:xfrm>
+          <a:prstGeom prst="rect">
+            <a:avLst/>
+          </a:prstGeom>
+          <a:noFill/>
+        </p:spPr>
+        <p:txBody>
+          <a:bodyPr wrap="square">
+            <a:spAutoFit/>
+          </a:bodyPr>
+          <a:lstStyle/>
+          <a:p>
+            <a:pPr algn="ctr">
+              <a:defRPr sz="2400" b="0" i="0">
+                <a:solidFill>
+                  <a:srgbClr val="4B5563"/>
+                </a:solidFill>
+                <a:latin typeface="Segoe UI"/>
+              </a:defRPr>
+            </a:pPr>
+            <a:r>
+              <a:t>→</a:t>
+            </a:r>
+          </a:p>
+        </p:txBody>
+      </p:sp>
+      <p:sp>
+        <p:nvSpPr>
+          <p:cNvPr id="9" name="Rounded Rectangle 8"/>
+          <p:cNvSpPr/>
+          <p:nvPr/>
+        </p:nvSpPr>
+        <p:spPr>
+          <a:xfrm>
+            <a:off x="6233007" y="1645920"/>
+            <a:ext cx="2468880" cy="1188720"/>
+          </a:xfrm>
+          <a:prstGeom prst="roundRect">
+            <a:avLst/>
+          </a:prstGeom>
+          <a:solidFill>
+            <a:srgbClr val="151D30"/>
+          </a:solidFill>
+          <a:ln w="19050">
+            <a:solidFill>
+              <a:srgbClr val="4B5563"/>
+            </a:solidFill>
+          </a:ln>
+        </p:spPr>
+        <p:style>
+          <a:lnRef idx="1">
+            <a:schemeClr val="accent1"/>
+          </a:lnRef>
+          <a:fillRef idx="3">
+            <a:schemeClr val="accent1"/>
+          </a:fillRef>
+          <a:effectRef idx="2">
+            <a:schemeClr val="accent1"/>
+          </a:effectRef>
+          <a:fontRef idx="minor">
+            <a:schemeClr val="lt1"/>
+          </a:fontRef>
+        </p:style>
+        <p:txBody>
+          <a:bodyPr rtlCol="0" anchor="ctr" wrap="square"/>
+          <a:lstStyle/>
+          <a:p>
+            <a:pPr algn="ctr">
+              <a:defRPr sz="2000" b="1">
+                <a:solidFill>
+                  <a:srgbClr val="F5F5F0"/>
+                </a:solidFill>
+                <a:latin typeface="Segoe UI"/>
+              </a:defRPr>
+            </a:pPr>
+            <a:r>
+              <a:t>Gen 3: Predictive</a:t>
+            </a:r>
+          </a:p>
+        </p:txBody>
+      </p:sp>
+      <p:sp>
+        <p:nvSpPr>
+          <p:cNvPr id="10" name="TextBox 9"/>
+          <p:cNvSpPr txBox="1"/>
+          <p:nvPr/>
+        </p:nvSpPr>
+        <p:spPr>
+          <a:xfrm>
+            <a:off x="6233007" y="3017520"/>
+            <a:ext cx="2468880" cy="1097280"/>
+          </a:xfrm>
+          <a:prstGeom prst="rect">
+            <a:avLst/>
+          </a:prstGeom>
+          <a:noFill/>
+        </p:spPr>
+        <p:txBody>
+          <a:bodyPr wrap="square">
+            <a:spAutoFit/>
+          </a:bodyPr>
+          <a:lstStyle/>
+          <a:p>
+            <a:pPr algn="ctr">
+              <a:defRPr sz="1500" b="0" i="0">
+                <a:solidFill>
+                  <a:srgbClr val="6B7280"/>
+                </a:solidFill>
+                <a:latin typeface="Segoe UI"/>
+              </a:defRPr>
+            </a:pPr>
+            <a:r>
+              <a:t>"Something</a:t>
+            </a:r>
+            <a:br/>
+            <a:r>
+              <a:t>will go wrong"</a:t>
+            </a:r>
+          </a:p>
+        </p:txBody>
+      </p:sp>
+      <p:sp>
+        <p:nvSpPr>
+          <p:cNvPr id="11" name="TextBox 10"/>
+          <p:cNvSpPr txBox="1"/>
+          <p:nvPr/>
+        </p:nvSpPr>
+        <p:spPr>
+          <a:xfrm>
+            <a:off x="8701887" y="1920240"/>
+            <a:ext cx="274320" cy="914400"/>
+          </a:xfrm>
+          <a:prstGeom prst="rect">
+            <a:avLst/>
+          </a:prstGeom>
+          <a:noFill/>
+        </p:spPr>
+        <p:txBody>
+          <a:bodyPr wrap="square">
+            <a:spAutoFit/>
+          </a:bodyPr>
+          <a:lstStyle/>
+          <a:p>
+            <a:pPr algn="ctr">
+              <a:defRPr sz="2400" b="0" i="0">
+                <a:solidFill>
+                  <a:srgbClr val="4B5563"/>
+                </a:solidFill>
+                <a:latin typeface="Segoe UI"/>
+              </a:defRPr>
+            </a:pPr>
+            <a:r>
+              <a:t>→</a:t>
+            </a:r>
+          </a:p>
+        </p:txBody>
+      </p:sp>
+      <p:sp>
+        <p:nvSpPr>
+          <p:cNvPr id="12" name="Rounded Rectangle 11"/>
+          <p:cNvSpPr/>
+          <p:nvPr/>
+        </p:nvSpPr>
+        <p:spPr>
+          <a:xfrm>
+            <a:off x="8976207" y="1645920"/>
+            <a:ext cx="2468880" cy="1188720"/>
+          </a:xfrm>
+          <a:prstGeom prst="roundRect">
+            <a:avLst/>
+          </a:prstGeom>
+          <a:noFill/>
+          <a:ln w="19050">
+            <a:solidFill>
+              <a:srgbClr val="D4D0C8"/>
+            </a:solidFill>
+          </a:ln>
+        </p:spPr>
+        <p:style>
+          <a:lnRef idx="1">
+            <a:schemeClr val="accent1"/>
+          </a:lnRef>
+          <a:fillRef idx="3">
+            <a:schemeClr val="accent1"/>
+          </a:fillRef>
+          <a:effectRef idx="2">
+            <a:schemeClr val="accent1"/>
+          </a:effectRef>
+          <a:fontRef idx="minor">
+            <a:schemeClr val="lt1"/>
+          </a:fontRef>
+        </p:style>
+        <p:txBody>
+          <a:bodyPr rtlCol="0" anchor="ctr" wrap="square"/>
+          <a:lstStyle/>
+          <a:p>
+            <a:pPr algn="ctr">
+              <a:defRPr sz="2000" b="1">
+                <a:solidFill>
+                  <a:srgbClr val="E8E4D9"/>
+                </a:solidFill>
+                <a:latin typeface="Segoe UI"/>
+              </a:defRPr>
+            </a:pPr>
+            <a:r>
+              <a:t>Gen 4: ?</a:t>
+            </a:r>
+          </a:p>
+        </p:txBody>
+      </p:sp>
+      <p:sp>
+        <p:nvSpPr>
+          <p:cNvPr id="13" name="TextBox 12"/>
+          <p:cNvSpPr txBox="1"/>
+          <p:nvPr/>
+        </p:nvSpPr>
+        <p:spPr>
+          <a:xfrm>
+            <a:off x="914400" y="4754880"/>
+            <a:ext cx="10058400" cy="1371600"/>
+          </a:xfrm>
+          <a:prstGeom prst="rect">
+            <a:avLst/>
+          </a:prstGeom>
+          <a:noFill/>
+        </p:spPr>
+        <p:txBody>
+          <a:bodyPr wrap="square">
+            <a:spAutoFit/>
+          </a:bodyPr>
+          <a:lstStyle/>
+          <a:p>
             <a:pPr algn="l">
-              <a:defRPr sz="3000" b="1" i="0">
+              <a:defRPr sz="2200" b="0" i="0">
                 <a:solidFill>
                   <a:srgbClr val="E8E4D9"/>
                 </a:solidFill>
@@ -7507,11 +8122,11 @@
               </a:defRPr>
             </a:pPr>
             <a:r>
-              <a:t>Your systems generate more data every hour</a:t>
+              <a:t>Each generation gets smarter about what's happening.</a:t>
             </a:r>
             <a:br/>
             <a:r>
-              <a:t>than your teams can act on in a week.</a:t>
+              <a:t>But the human is still the one who decides what to do about it.</a:t>
             </a:r>
           </a:p>
         </p:txBody>
@@ -7558,8 +8173,8 @@
         </p:nvSpPr>
         <p:spPr>
           <a:xfrm>
-            <a:off x="1097280" y="457200"/>
-            <a:ext cx="4572000" cy="457200"/>
+            <a:off x="1371600" y="2286000"/>
+            <a:ext cx="9144000" cy="2743200"/>
           </a:xfrm>
           <a:prstGeom prst="rect">
             <a:avLst/>
@@ -7573,501 +8188,23 @@
           <a:lstStyle/>
           <a:p>
             <a:pPr algn="l">
-              <a:defRPr sz="1400" b="0" i="0">
-                <a:solidFill>
-                  <a:srgbClr val="4B5563"/>
-                </a:solidFill>
-                <a:latin typeface="Segoe UI"/>
-              </a:defRPr>
-            </a:pPr>
-            <a:r>
-              <a:t>The Evolution</a:t>
-            </a:r>
-          </a:p>
-        </p:txBody>
-      </p:sp>
-      <p:sp>
-        <p:nvSpPr>
-          <p:cNvPr id="3" name="Rounded Rectangle 2"/>
-          <p:cNvSpPr/>
-          <p:nvPr/>
-        </p:nvSpPr>
-        <p:spPr>
-          <a:xfrm>
-            <a:off x="914400" y="1645920"/>
-            <a:ext cx="2468880" cy="1188720"/>
-          </a:xfrm>
-          <a:prstGeom prst="roundRect">
-            <a:avLst/>
-          </a:prstGeom>
-          <a:solidFill>
-            <a:srgbClr val="151D30"/>
-          </a:solidFill>
-          <a:ln w="19050">
-            <a:solidFill>
-              <a:srgbClr val="4B5563"/>
-            </a:solidFill>
-          </a:ln>
-        </p:spPr>
-        <p:style>
-          <a:lnRef idx="1">
-            <a:schemeClr val="accent1"/>
-          </a:lnRef>
-          <a:fillRef idx="3">
-            <a:schemeClr val="accent1"/>
-          </a:fillRef>
-          <a:effectRef idx="2">
-            <a:schemeClr val="accent1"/>
-          </a:effectRef>
-          <a:fontRef idx="minor">
-            <a:schemeClr val="lt1"/>
-          </a:fontRef>
-        </p:style>
-        <p:txBody>
-          <a:bodyPr rtlCol="0" anchor="ctr" wrap="square"/>
-          <a:lstStyle/>
-          <a:p>
-            <a:pPr algn="ctr">
-              <a:defRPr sz="2000" b="1">
-                <a:solidFill>
-                  <a:srgbClr val="F5F5F0"/>
-                </a:solidFill>
-                <a:latin typeface="Segoe UI"/>
-              </a:defRPr>
-            </a:pPr>
-            <a:r>
-              <a:t>Gen 1: Static</a:t>
-            </a:r>
-          </a:p>
-        </p:txBody>
-      </p:sp>
-      <p:sp>
-        <p:nvSpPr>
-          <p:cNvPr id="4" name="TextBox 3"/>
-          <p:cNvSpPr txBox="1"/>
-          <p:nvPr/>
-        </p:nvSpPr>
-        <p:spPr>
-          <a:xfrm>
-            <a:off x="914400" y="3017520"/>
-            <a:ext cx="2468880" cy="1097280"/>
-          </a:xfrm>
-          <a:prstGeom prst="rect">
-            <a:avLst/>
-          </a:prstGeom>
-          <a:noFill/>
-        </p:spPr>
-        <p:txBody>
-          <a:bodyPr wrap="square">
-            <a:spAutoFit/>
-          </a:bodyPr>
-          <a:lstStyle/>
-          <a:p>
-            <a:pPr algn="ctr">
-              <a:defRPr sz="1500" b="0" i="0">
-                <a:solidFill>
-                  <a:srgbClr val="6B7280"/>
-                </a:solidFill>
-                <a:latin typeface="Segoe UI"/>
-              </a:defRPr>
-            </a:pPr>
-            <a:r>
-              <a:t>"Here's what</a:t>
+              <a:defRPr sz="4200" b="1" i="0">
+                <a:solidFill>
+                  <a:srgbClr val="E8E4D9"/>
+                </a:solidFill>
+                <a:latin typeface="Segoe UI"/>
+              </a:defRPr>
+            </a:pPr>
+            <a:r>
+              <a:t>Digital twins can see everything.</a:t>
             </a:r>
             <a:br/>
             <a:r>
-              <a:t>it looks like"</a:t>
-            </a:r>
-          </a:p>
-        </p:txBody>
-      </p:sp>
-      <p:sp>
-        <p:nvSpPr>
-          <p:cNvPr id="5" name="TextBox 4"/>
-          <p:cNvSpPr txBox="1"/>
-          <p:nvPr/>
-        </p:nvSpPr>
-        <p:spPr>
-          <a:xfrm>
-            <a:off x="3291840" y="1828800"/>
-            <a:ext cx="548640" cy="731520"/>
-          </a:xfrm>
-          <a:prstGeom prst="rect">
-            <a:avLst/>
-          </a:prstGeom>
-          <a:noFill/>
-        </p:spPr>
-        <p:txBody>
-          <a:bodyPr wrap="square">
-            <a:spAutoFit/>
-          </a:bodyPr>
-          <a:lstStyle/>
-          <a:p>
-            <a:pPr algn="ctr">
-              <a:defRPr sz="2400" b="0" i="0">
-                <a:solidFill>
-                  <a:srgbClr val="4B5563"/>
-                </a:solidFill>
-                <a:latin typeface="Segoe UI"/>
-              </a:defRPr>
-            </a:pPr>
-            <a:r>
-              <a:t>→</a:t>
-            </a:r>
-          </a:p>
-        </p:txBody>
-      </p:sp>
-      <p:sp>
-        <p:nvSpPr>
-          <p:cNvPr id="6" name="Rounded Rectangle 5"/>
-          <p:cNvSpPr/>
-          <p:nvPr/>
-        </p:nvSpPr>
-        <p:spPr>
-          <a:xfrm>
-            <a:off x="3749039" y="1645920"/>
-            <a:ext cx="2468880" cy="1188720"/>
-          </a:xfrm>
-          <a:prstGeom prst="roundRect">
-            <a:avLst/>
-          </a:prstGeom>
-          <a:solidFill>
-            <a:srgbClr val="151D30"/>
-          </a:solidFill>
-          <a:ln w="19050">
-            <a:solidFill>
-              <a:srgbClr val="4B5563"/>
-            </a:solidFill>
-          </a:ln>
-        </p:spPr>
-        <p:style>
-          <a:lnRef idx="1">
-            <a:schemeClr val="accent1"/>
-          </a:lnRef>
-          <a:fillRef idx="3">
-            <a:schemeClr val="accent1"/>
-          </a:fillRef>
-          <a:effectRef idx="2">
-            <a:schemeClr val="accent1"/>
-          </a:effectRef>
-          <a:fontRef idx="minor">
-            <a:schemeClr val="lt1"/>
-          </a:fontRef>
-        </p:style>
-        <p:txBody>
-          <a:bodyPr rtlCol="0" anchor="ctr" wrap="square"/>
-          <a:lstStyle/>
-          <a:p>
-            <a:pPr algn="ctr">
-              <a:defRPr sz="2000" b="1">
-                <a:solidFill>
-                  <a:srgbClr val="F5F5F0"/>
-                </a:solidFill>
-                <a:latin typeface="Segoe UI"/>
-              </a:defRPr>
-            </a:pPr>
-            <a:r>
-              <a:t>Gen 2: Reactive</a:t>
-            </a:r>
-          </a:p>
-        </p:txBody>
-      </p:sp>
-      <p:sp>
-        <p:nvSpPr>
-          <p:cNvPr id="7" name="TextBox 6"/>
-          <p:cNvSpPr txBox="1"/>
-          <p:nvPr/>
-        </p:nvSpPr>
-        <p:spPr>
-          <a:xfrm>
-            <a:off x="3749039" y="3017520"/>
-            <a:ext cx="2468880" cy="1097280"/>
-          </a:xfrm>
-          <a:prstGeom prst="rect">
-            <a:avLst/>
-          </a:prstGeom>
-          <a:noFill/>
-        </p:spPr>
-        <p:txBody>
-          <a:bodyPr wrap="square">
-            <a:spAutoFit/>
-          </a:bodyPr>
-          <a:lstStyle/>
-          <a:p>
-            <a:pPr algn="ctr">
-              <a:defRPr sz="1500" b="0" i="0">
-                <a:solidFill>
-                  <a:srgbClr val="6B7280"/>
-                </a:solidFill>
-                <a:latin typeface="Segoe UI"/>
-              </a:defRPr>
-            </a:pPr>
-            <a:r>
-              <a:t>"Something</a:t>
+              <a:t>They can't do anything</a:t>
             </a:r>
             <a:br/>
             <a:r>
-              <a:t>went wrong"</a:t>
-            </a:r>
-          </a:p>
-        </p:txBody>
-      </p:sp>
-      <p:sp>
-        <p:nvSpPr>
-          <p:cNvPr id="8" name="TextBox 7"/>
-          <p:cNvSpPr txBox="1"/>
-          <p:nvPr/>
-        </p:nvSpPr>
-        <p:spPr>
-          <a:xfrm>
-            <a:off x="6126479" y="1828800"/>
-            <a:ext cx="548640" cy="731520"/>
-          </a:xfrm>
-          <a:prstGeom prst="rect">
-            <a:avLst/>
-          </a:prstGeom>
-          <a:noFill/>
-        </p:spPr>
-        <p:txBody>
-          <a:bodyPr wrap="square">
-            <a:spAutoFit/>
-          </a:bodyPr>
-          <a:lstStyle/>
-          <a:p>
-            <a:pPr algn="ctr">
-              <a:defRPr sz="2400" b="0" i="0">
-                <a:solidFill>
-                  <a:srgbClr val="4B5563"/>
-                </a:solidFill>
-                <a:latin typeface="Segoe UI"/>
-              </a:defRPr>
-            </a:pPr>
-            <a:r>
-              <a:t>→</a:t>
-            </a:r>
-          </a:p>
-        </p:txBody>
-      </p:sp>
-      <p:sp>
-        <p:nvSpPr>
-          <p:cNvPr id="9" name="Rounded Rectangle 8"/>
-          <p:cNvSpPr/>
-          <p:nvPr/>
-        </p:nvSpPr>
-        <p:spPr>
-          <a:xfrm>
-            <a:off x="6583680" y="1645920"/>
-            <a:ext cx="2468880" cy="1188720"/>
-          </a:xfrm>
-          <a:prstGeom prst="roundRect">
-            <a:avLst/>
-          </a:prstGeom>
-          <a:solidFill>
-            <a:srgbClr val="151D30"/>
-          </a:solidFill>
-          <a:ln w="19050">
-            <a:solidFill>
-              <a:srgbClr val="4B5563"/>
-            </a:solidFill>
-          </a:ln>
-        </p:spPr>
-        <p:style>
-          <a:lnRef idx="1">
-            <a:schemeClr val="accent1"/>
-          </a:lnRef>
-          <a:fillRef idx="3">
-            <a:schemeClr val="accent1"/>
-          </a:fillRef>
-          <a:effectRef idx="2">
-            <a:schemeClr val="accent1"/>
-          </a:effectRef>
-          <a:fontRef idx="minor">
-            <a:schemeClr val="lt1"/>
-          </a:fontRef>
-        </p:style>
-        <p:txBody>
-          <a:bodyPr rtlCol="0" anchor="ctr" wrap="square"/>
-          <a:lstStyle/>
-          <a:p>
-            <a:pPr algn="ctr">
-              <a:defRPr sz="2000" b="1">
-                <a:solidFill>
-                  <a:srgbClr val="F5F5F0"/>
-                </a:solidFill>
-                <a:latin typeface="Segoe UI"/>
-              </a:defRPr>
-            </a:pPr>
-            <a:r>
-              <a:t>Gen 3: Predictive</a:t>
-            </a:r>
-          </a:p>
-        </p:txBody>
-      </p:sp>
-      <p:sp>
-        <p:nvSpPr>
-          <p:cNvPr id="10" name="TextBox 9"/>
-          <p:cNvSpPr txBox="1"/>
-          <p:nvPr/>
-        </p:nvSpPr>
-        <p:spPr>
-          <a:xfrm>
-            <a:off x="6583680" y="3017520"/>
-            <a:ext cx="2468880" cy="1097280"/>
-          </a:xfrm>
-          <a:prstGeom prst="rect">
-            <a:avLst/>
-          </a:prstGeom>
-          <a:noFill/>
-        </p:spPr>
-        <p:txBody>
-          <a:bodyPr wrap="square">
-            <a:spAutoFit/>
-          </a:bodyPr>
-          <a:lstStyle/>
-          <a:p>
-            <a:pPr algn="ctr">
-              <a:defRPr sz="1500" b="0" i="0">
-                <a:solidFill>
-                  <a:srgbClr val="6B7280"/>
-                </a:solidFill>
-                <a:latin typeface="Segoe UI"/>
-              </a:defRPr>
-            </a:pPr>
-            <a:r>
-              <a:t>"Something</a:t>
-            </a:r>
-            <a:br/>
-            <a:r>
-              <a:t>will go wrong"</a:t>
-            </a:r>
-          </a:p>
-        </p:txBody>
-      </p:sp>
-      <p:sp>
-        <p:nvSpPr>
-          <p:cNvPr id="11" name="TextBox 10"/>
-          <p:cNvSpPr txBox="1"/>
-          <p:nvPr/>
-        </p:nvSpPr>
-        <p:spPr>
-          <a:xfrm>
-            <a:off x="8961120" y="1828800"/>
-            <a:ext cx="548640" cy="731520"/>
-          </a:xfrm>
-          <a:prstGeom prst="rect">
-            <a:avLst/>
-          </a:prstGeom>
-          <a:noFill/>
-        </p:spPr>
-        <p:txBody>
-          <a:bodyPr wrap="square">
-            <a:spAutoFit/>
-          </a:bodyPr>
-          <a:lstStyle/>
-          <a:p>
-            <a:pPr algn="ctr">
-              <a:defRPr sz="2400" b="0" i="0">
-                <a:solidFill>
-                  <a:srgbClr val="4B5563"/>
-                </a:solidFill>
-                <a:latin typeface="Segoe UI"/>
-              </a:defRPr>
-            </a:pPr>
-            <a:r>
-              <a:t>→</a:t>
-            </a:r>
-          </a:p>
-        </p:txBody>
-      </p:sp>
-      <p:sp>
-        <p:nvSpPr>
-          <p:cNvPr id="12" name="Rounded Rectangle 11"/>
-          <p:cNvSpPr/>
-          <p:nvPr/>
-        </p:nvSpPr>
-        <p:spPr>
-          <a:xfrm>
-            <a:off x="9418320" y="1645920"/>
-            <a:ext cx="2468880" cy="1188720"/>
-          </a:xfrm>
-          <a:prstGeom prst="roundRect">
-            <a:avLst/>
-          </a:prstGeom>
-          <a:noFill/>
-          <a:ln w="19050">
-            <a:solidFill>
-              <a:srgbClr val="D4D0C8"/>
-            </a:solidFill>
-          </a:ln>
-        </p:spPr>
-        <p:style>
-          <a:lnRef idx="1">
-            <a:schemeClr val="accent1"/>
-          </a:lnRef>
-          <a:fillRef idx="3">
-            <a:schemeClr val="accent1"/>
-          </a:fillRef>
-          <a:effectRef idx="2">
-            <a:schemeClr val="accent1"/>
-          </a:effectRef>
-          <a:fontRef idx="minor">
-            <a:schemeClr val="lt1"/>
-          </a:fontRef>
-        </p:style>
-        <p:txBody>
-          <a:bodyPr rtlCol="0" anchor="ctr" wrap="square"/>
-          <a:lstStyle/>
-          <a:p>
-            <a:pPr algn="ctr">
-              <a:defRPr sz="2000" b="1">
-                <a:solidFill>
-                  <a:srgbClr val="E8E4D9"/>
-                </a:solidFill>
-                <a:latin typeface="Segoe UI"/>
-              </a:defRPr>
-            </a:pPr>
-            <a:r>
-              <a:t>Gen 4: ?</a:t>
-            </a:r>
-          </a:p>
-        </p:txBody>
-      </p:sp>
-      <p:sp>
-        <p:nvSpPr>
-          <p:cNvPr id="13" name="TextBox 12"/>
-          <p:cNvSpPr txBox="1"/>
-          <p:nvPr/>
-        </p:nvSpPr>
-        <p:spPr>
-          <a:xfrm>
-            <a:off x="914400" y="4754880"/>
-            <a:ext cx="10058400" cy="1371600"/>
-          </a:xfrm>
-          <a:prstGeom prst="rect">
-            <a:avLst/>
-          </a:prstGeom>
-          <a:noFill/>
-        </p:spPr>
-        <p:txBody>
-          <a:bodyPr wrap="square">
-            <a:spAutoFit/>
-          </a:bodyPr>
-          <a:lstStyle/>
-          <a:p>
-            <a:pPr algn="l">
-              <a:defRPr sz="2200" b="0" i="0">
-                <a:solidFill>
-                  <a:srgbClr val="E8E4D9"/>
-                </a:solidFill>
-                <a:latin typeface="Segoe UI"/>
-              </a:defRPr>
-            </a:pPr>
-            <a:r>
-              <a:t>Each generation gets smarter about what's happening.</a:t>
-            </a:r>
-            <a:br/>
-            <a:r>
-              <a:t>But the human is still the one who decides what to do about it.</a:t>
+              <a:t>about what they see.</a:t>
             </a:r>
           </a:p>
         </p:txBody>
@@ -8108,59 +8245,14 @@
       <p:grpSpPr/>
       <p:sp>
         <p:nvSpPr>
-          <p:cNvPr id="2" name="Rounded Rectangle 1"/>
-          <p:cNvSpPr/>
-          <p:nvPr/>
-        </p:nvSpPr>
-        <p:spPr>
-          <a:xfrm>
-            <a:off x="457200" y="274320"/>
-            <a:ext cx="11247120" cy="6309360"/>
-          </a:xfrm>
-          <a:prstGeom prst="roundRect">
-            <a:avLst/>
-          </a:prstGeom>
-          <a:solidFill>
-            <a:srgbClr val="0B1120"/>
-          </a:solidFill>
-          <a:ln w="19050">
-            <a:solidFill>
-              <a:srgbClr val="4B5563"/>
-            </a:solidFill>
-          </a:ln>
-        </p:spPr>
-        <p:style>
-          <a:lnRef idx="1">
-            <a:schemeClr val="accent1"/>
-          </a:lnRef>
-          <a:fillRef idx="3">
-            <a:schemeClr val="accent1"/>
-          </a:fillRef>
-          <a:effectRef idx="2">
-            <a:schemeClr val="accent1"/>
-          </a:effectRef>
-          <a:fontRef idx="minor">
-            <a:schemeClr val="lt1"/>
-          </a:fontRef>
-        </p:style>
-        <p:txBody>
-          <a:bodyPr rtlCol="0" anchor="ctr"/>
-          <a:lstStyle/>
-          <a:p>
-            <a:pPr algn="ctr"/>
-          </a:p>
-        </p:txBody>
-      </p:sp>
-      <p:sp>
-        <p:nvSpPr>
-          <p:cNvPr id="3" name="TextBox 2"/>
+          <p:cNvPr id="2" name="TextBox 1"/>
           <p:cNvSpPr txBox="1"/>
           <p:nvPr/>
         </p:nvSpPr>
         <p:spPr>
           <a:xfrm>
-            <a:off x="1371600" y="914400"/>
-            <a:ext cx="4572000" cy="731520"/>
+            <a:off x="1371600" y="2011680"/>
+            <a:ext cx="9144000" cy="1371600"/>
           </a:xfrm>
           <a:prstGeom prst="rect">
             <a:avLst/>
@@ -8174,7 +8266,7 @@
           <a:lstStyle/>
           <a:p>
             <a:pPr algn="l">
-              <a:defRPr sz="5200" b="1" i="0">
+              <a:defRPr sz="7200" b="1" i="0">
                 <a:solidFill>
                   <a:srgbClr val="F5F5F0"/>
                 </a:solidFill>
@@ -8182,21 +8274,21 @@
               </a:defRPr>
             </a:pPr>
             <a:r>
-              <a:t>2:00 AM</a:t>
-            </a:r>
-          </a:p>
-        </p:txBody>
-      </p:sp>
-      <p:sp>
-        <p:nvSpPr>
-          <p:cNvPr id="4" name="TextBox 3"/>
+              <a:t>2:14 AM</a:t>
+            </a:r>
+          </a:p>
+        </p:txBody>
+      </p:sp>
+      <p:sp>
+        <p:nvSpPr>
+          <p:cNvPr id="3" name="TextBox 2"/>
           <p:cNvSpPr txBox="1"/>
           <p:nvPr/>
         </p:nvSpPr>
         <p:spPr>
           <a:xfrm>
-            <a:off x="1371600" y="1737360"/>
-            <a:ext cx="7315200" cy="457200"/>
+            <a:off x="1371600" y="3657600"/>
+            <a:ext cx="9144000" cy="731520"/>
           </a:xfrm>
           <a:prstGeom prst="rect">
             <a:avLst/>
@@ -8210,7 +8302,7 @@
           <a:lstStyle/>
           <a:p>
             <a:pPr algn="l">
-              <a:defRPr sz="2000" b="0" i="0">
+              <a:defRPr sz="2400" b="0" i="0">
                 <a:solidFill>
                   <a:srgbClr val="6B7280"/>
                 </a:solidFill>
@@ -8218,382 +8310,7 @@
               </a:defRPr>
             </a:pPr>
             <a:r>
-              <a:t>Etch chamber 3 — temperature drift detected</a:t>
-            </a:r>
-          </a:p>
-        </p:txBody>
-      </p:sp>
-      <p:sp>
-        <p:nvSpPr>
-          <p:cNvPr id="5" name="Rectangle 4"/>
-          <p:cNvSpPr/>
-          <p:nvPr/>
-        </p:nvSpPr>
-        <p:spPr>
-          <a:xfrm>
-            <a:off x="1371600" y="2560320"/>
-            <a:ext cx="1371600" cy="10972"/>
-          </a:xfrm>
-          <a:prstGeom prst="rect">
-            <a:avLst/>
-          </a:prstGeom>
-          <a:solidFill>
-            <a:srgbClr val="D4D0C8"/>
-          </a:solidFill>
-          <a:ln>
-            <a:noFill/>
-          </a:ln>
-        </p:spPr>
-        <p:style>
-          <a:lnRef idx="1">
-            <a:schemeClr val="accent1"/>
-          </a:lnRef>
-          <a:fillRef idx="3">
-            <a:schemeClr val="accent1"/>
-          </a:fillRef>
-          <a:effectRef idx="2">
-            <a:schemeClr val="accent1"/>
-          </a:effectRef>
-          <a:fontRef idx="minor">
-            <a:schemeClr val="lt1"/>
-          </a:fontRef>
-        </p:style>
-        <p:txBody>
-          <a:bodyPr rtlCol="0" anchor="ctr"/>
-          <a:lstStyle/>
-          <a:p>
-            <a:pPr algn="ctr"/>
-          </a:p>
-        </p:txBody>
-      </p:sp>
-      <p:sp>
-        <p:nvSpPr>
-          <p:cNvPr id="6" name="TextBox 5"/>
-          <p:cNvSpPr txBox="1"/>
-          <p:nvPr/>
-        </p:nvSpPr>
-        <p:spPr>
-          <a:xfrm>
-            <a:off x="1371600" y="2926080"/>
-            <a:ext cx="4572000" cy="457200"/>
-          </a:xfrm>
-          <a:prstGeom prst="rect">
-            <a:avLst/>
-          </a:prstGeom>
-          <a:noFill/>
-        </p:spPr>
-        <p:txBody>
-          <a:bodyPr wrap="square">
-            <a:spAutoFit/>
-          </a:bodyPr>
-          <a:lstStyle/>
-          <a:p>
-            <a:pPr algn="l">
-              <a:defRPr sz="1800" b="1" i="0">
-                <a:solidFill>
-                  <a:srgbClr val="E8E4D9"/>
-                </a:solidFill>
-                <a:latin typeface="Segoe UI"/>
-              </a:defRPr>
-            </a:pPr>
-            <a:r>
-              <a:t>The twin detected:</a:t>
-            </a:r>
-          </a:p>
-        </p:txBody>
-      </p:sp>
-      <p:sp>
-        <p:nvSpPr>
-          <p:cNvPr id="7" name="TextBox 6"/>
-          <p:cNvSpPr txBox="1"/>
-          <p:nvPr/>
-        </p:nvSpPr>
-        <p:spPr>
-          <a:xfrm>
-            <a:off x="1371600" y="3383280"/>
-            <a:ext cx="4572000" cy="457200"/>
-          </a:xfrm>
-          <a:prstGeom prst="rect">
-            <a:avLst/>
-          </a:prstGeom>
-          <a:noFill/>
-        </p:spPr>
-        <p:txBody>
-          <a:bodyPr wrap="square">
-            <a:spAutoFit/>
-          </a:bodyPr>
-          <a:lstStyle/>
-          <a:p>
-            <a:pPr algn="l">
-              <a:defRPr sz="1600" b="0" i="0">
-                <a:solidFill>
-                  <a:srgbClr val="6B7280"/>
-                </a:solidFill>
-                <a:latin typeface="Segoe UI"/>
-              </a:defRPr>
-            </a:pPr>
-            <a:r>
-              <a:t>Temperature crossing a threshold. That's it.</a:t>
-            </a:r>
-          </a:p>
-        </p:txBody>
-      </p:sp>
-      <p:sp>
-        <p:nvSpPr>
-          <p:cNvPr id="8" name="TextBox 7"/>
-          <p:cNvSpPr txBox="1"/>
-          <p:nvPr/>
-        </p:nvSpPr>
-        <p:spPr>
-          <a:xfrm>
-            <a:off x="1371600" y="4114800"/>
-            <a:ext cx="4572000" cy="457200"/>
-          </a:xfrm>
-          <a:prstGeom prst="rect">
-            <a:avLst/>
-          </a:prstGeom>
-          <a:noFill/>
-        </p:spPr>
-        <p:txBody>
-          <a:bodyPr wrap="square">
-            <a:spAutoFit/>
-          </a:bodyPr>
-          <a:lstStyle/>
-          <a:p>
-            <a:pPr algn="l">
-              <a:defRPr sz="1800" b="1" i="0">
-                <a:solidFill>
-                  <a:srgbClr val="E8E4D9"/>
-                </a:solidFill>
-                <a:latin typeface="Segoe UI"/>
-              </a:defRPr>
-            </a:pPr>
-            <a:r>
-              <a:t>The twin didn't know:</a:t>
-            </a:r>
-          </a:p>
-        </p:txBody>
-      </p:sp>
-      <p:sp>
-        <p:nvSpPr>
-          <p:cNvPr id="9" name="TextBox 8"/>
-          <p:cNvSpPr txBox="1"/>
-          <p:nvPr/>
-        </p:nvSpPr>
-        <p:spPr>
-          <a:xfrm>
-            <a:off x="1371600" y="4572000"/>
-            <a:ext cx="4572000" cy="1828800"/>
-          </a:xfrm>
-          <a:prstGeom prst="rect">
-            <a:avLst/>
-          </a:prstGeom>
-          <a:noFill/>
-        </p:spPr>
-        <p:txBody>
-          <a:bodyPr wrap="square">
-            <a:spAutoFit/>
-          </a:bodyPr>
-          <a:lstStyle/>
-          <a:p>
-            <a:pPr algn="l">
-              <a:spcBef>
-                <a:spcPts val="600"/>
-              </a:spcBef>
-              <a:spcAft>
-                <a:spcPts val="600"/>
-              </a:spcAft>
-              <a:defRPr sz="1600" b="0">
-                <a:solidFill>
-                  <a:srgbClr val="6B7280"/>
-                </a:solidFill>
-                <a:latin typeface="Segoe UI"/>
-              </a:defRPr>
-            </a:pPr>
-            <a:r>
-              <a:t>It was a failing heater element.</a:t>
-            </a:r>
-          </a:p>
-          <a:p>
-            <a:pPr algn="l">
-              <a:spcBef>
-                <a:spcPts val="600"/>
-              </a:spcBef>
-              <a:spcAft>
-                <a:spcPts val="600"/>
-              </a:spcAft>
-              <a:defRPr sz="1600" b="0">
-                <a:solidFill>
-                  <a:srgbClr val="6B7280"/>
-                </a:solidFill>
-                <a:latin typeface="Segoe UI"/>
-              </a:defRPr>
-            </a:pPr>
-            <a:r>
-              <a:t>This happened 6 months ago on another chamber.</a:t>
-            </a:r>
-          </a:p>
-          <a:p>
-            <a:pPr algn="l">
-              <a:spcBef>
-                <a:spcPts val="600"/>
-              </a:spcBef>
-              <a:spcAft>
-                <a:spcPts val="600"/>
-              </a:spcAft>
-              <a:defRPr sz="1600" b="0">
-                <a:solidFill>
-                  <a:srgbClr val="6B7280"/>
-                </a:solidFill>
-                <a:latin typeface="Segoe UI"/>
-              </a:defRPr>
-            </a:pPr>
-            <a:r>
-              <a:t>A replacement part was already in inventory.</a:t>
-            </a:r>
-          </a:p>
-        </p:txBody>
-      </p:sp>
-      <p:sp>
-        <p:nvSpPr>
-          <p:cNvPr id="10" name="TextBox 9"/>
-          <p:cNvSpPr txBox="1"/>
-          <p:nvPr/>
-        </p:nvSpPr>
-        <p:spPr>
-          <a:xfrm>
-            <a:off x="6858000" y="2926080"/>
-            <a:ext cx="4114800" cy="457200"/>
-          </a:xfrm>
-          <a:prstGeom prst="rect">
-            <a:avLst/>
-          </a:prstGeom>
-          <a:noFill/>
-        </p:spPr>
-        <p:txBody>
-          <a:bodyPr wrap="square">
-            <a:spAutoFit/>
-          </a:bodyPr>
-          <a:lstStyle/>
-          <a:p>
-            <a:pPr algn="l">
-              <a:defRPr sz="1600" b="0" i="0">
-                <a:solidFill>
-                  <a:srgbClr val="6B7280"/>
-                </a:solidFill>
-                <a:latin typeface="Segoe UI"/>
-              </a:defRPr>
-            </a:pPr>
-            <a:r>
-              <a:t>Detected in</a:t>
-            </a:r>
-          </a:p>
-        </p:txBody>
-      </p:sp>
-      <p:sp>
-        <p:nvSpPr>
-          <p:cNvPr id="11" name="TextBox 10"/>
-          <p:cNvSpPr txBox="1"/>
-          <p:nvPr/>
-        </p:nvSpPr>
-        <p:spPr>
-          <a:xfrm>
-            <a:off x="6858000" y="3383280"/>
-            <a:ext cx="4114800" cy="731520"/>
-          </a:xfrm>
-          <a:prstGeom prst="rect">
-            <a:avLst/>
-          </a:prstGeom>
-          <a:noFill/>
-        </p:spPr>
-        <p:txBody>
-          <a:bodyPr wrap="square">
-            <a:spAutoFit/>
-          </a:bodyPr>
-          <a:lstStyle/>
-          <a:p>
-            <a:pPr algn="l">
-              <a:defRPr sz="3600" b="1" i="0">
-                <a:solidFill>
-                  <a:srgbClr val="E8E4D9"/>
-                </a:solidFill>
-                <a:latin typeface="Segoe UI"/>
-              </a:defRPr>
-            </a:pPr>
-            <a:r>
-              <a:t>30 seconds</a:t>
-            </a:r>
-          </a:p>
-        </p:txBody>
-      </p:sp>
-      <p:sp>
-        <p:nvSpPr>
-          <p:cNvPr id="12" name="TextBox 11"/>
-          <p:cNvSpPr txBox="1"/>
-          <p:nvPr/>
-        </p:nvSpPr>
-        <p:spPr>
-          <a:xfrm>
-            <a:off x="6858000" y="4389120"/>
-            <a:ext cx="4114800" cy="457200"/>
-          </a:xfrm>
-          <a:prstGeom prst="rect">
-            <a:avLst/>
-          </a:prstGeom>
-          <a:noFill/>
-        </p:spPr>
-        <p:txBody>
-          <a:bodyPr wrap="square">
-            <a:spAutoFit/>
-          </a:bodyPr>
-          <a:lstStyle/>
-          <a:p>
-            <a:pPr algn="l">
-              <a:defRPr sz="1600" b="0" i="0">
-                <a:solidFill>
-                  <a:srgbClr val="6B7280"/>
-                </a:solidFill>
-                <a:latin typeface="Segoe UI"/>
-              </a:defRPr>
-            </a:pPr>
-            <a:r>
-              <a:t>Resolved in</a:t>
-            </a:r>
-          </a:p>
-        </p:txBody>
-      </p:sp>
-      <p:sp>
-        <p:nvSpPr>
-          <p:cNvPr id="13" name="TextBox 12"/>
-          <p:cNvSpPr txBox="1"/>
-          <p:nvPr/>
-        </p:nvSpPr>
-        <p:spPr>
-          <a:xfrm>
-            <a:off x="6858000" y="4846320"/>
-            <a:ext cx="4114800" cy="731520"/>
-          </a:xfrm>
-          <a:prstGeom prst="rect">
-            <a:avLst/>
-          </a:prstGeom>
-          <a:noFill/>
-        </p:spPr>
-        <p:txBody>
-          <a:bodyPr wrap="square">
-            <a:spAutoFit/>
-          </a:bodyPr>
-          <a:lstStyle/>
-          <a:p>
-            <a:pPr algn="l">
-              <a:defRPr sz="3600" b="1" i="0">
-                <a:solidFill>
-                  <a:srgbClr val="F5F5F0"/>
-                </a:solidFill>
-                <a:latin typeface="Segoe UI"/>
-              </a:defRPr>
-            </a:pPr>
-            <a:r>
-              <a:t>14 hours</a:t>
+              <a:t>Etch chamber 3.</a:t>
             </a:r>
           </a:p>
         </p:txBody>
@@ -8782,7 +8499,7 @@
         </p:nvSpPr>
         <p:spPr>
           <a:xfrm>
-            <a:off x="914400" y="1828800"/>
+            <a:off x="746607" y="1828800"/>
             <a:ext cx="2468880" cy="1097280"/>
           </a:xfrm>
           <a:prstGeom prst="roundRect">
@@ -8837,7 +8554,7 @@
         </p:nvSpPr>
         <p:spPr>
           <a:xfrm>
-            <a:off x="1051560" y="3200400"/>
+            <a:off x="883767" y="3200400"/>
             <a:ext cx="2286000" cy="1645920"/>
           </a:xfrm>
           <a:prstGeom prst="rect">
@@ -8881,7 +8598,7 @@
         </p:nvSpPr>
         <p:spPr>
           <a:xfrm>
-            <a:off x="3749039" y="1828800"/>
+            <a:off x="3489807" y="1828800"/>
             <a:ext cx="2468880" cy="1097280"/>
           </a:xfrm>
           <a:prstGeom prst="roundRect">
@@ -8936,7 +8653,7 @@
         </p:nvSpPr>
         <p:spPr>
           <a:xfrm>
-            <a:off x="3886199" y="3200400"/>
+            <a:off x="3626967" y="3200400"/>
             <a:ext cx="2286000" cy="1645920"/>
           </a:xfrm>
           <a:prstGeom prst="rect">
@@ -8980,7 +8697,7 @@
         </p:nvSpPr>
         <p:spPr>
           <a:xfrm>
-            <a:off x="6583680" y="1828800"/>
+            <a:off x="6233007" y="1828800"/>
             <a:ext cx="2468880" cy="1097280"/>
           </a:xfrm>
           <a:prstGeom prst="roundRect">
@@ -9035,7 +8752,7 @@
         </p:nvSpPr>
         <p:spPr>
           <a:xfrm>
-            <a:off x="6720840" y="3200400"/>
+            <a:off x="6370167" y="3200400"/>
             <a:ext cx="2286000" cy="1645920"/>
           </a:xfrm>
           <a:prstGeom prst="rect">
@@ -9079,7 +8796,7 @@
         </p:nvSpPr>
         <p:spPr>
           <a:xfrm>
-            <a:off x="9418320" y="1828800"/>
+            <a:off x="8976207" y="1828800"/>
             <a:ext cx="2468880" cy="1097280"/>
           </a:xfrm>
           <a:prstGeom prst="roundRect">
@@ -9134,7 +8851,7 @@
         </p:nvSpPr>
         <p:spPr>
           <a:xfrm>
-            <a:off x="9555480" y="3200400"/>
+            <a:off x="9113367" y="3200400"/>
             <a:ext cx="2286000" cy="1645920"/>
           </a:xfrm>
           <a:prstGeom prst="rect">
@@ -9218,9 +8935,7 @@
           <a:prstGeom prst="ellipse">
             <a:avLst/>
           </a:prstGeom>
-          <a:solidFill>
-            <a:srgbClr val="151D30"/>
-          </a:solidFill>
+          <a:noFill/>
           <a:ln w="19050">
             <a:solidFill>
               <a:srgbClr val="D4D0C8"/>
@@ -9347,9 +9062,7 @@
           <a:prstGeom prst="ellipse">
             <a:avLst/>
           </a:prstGeom>
-          <a:solidFill>
-            <a:srgbClr val="151D30"/>
-          </a:solidFill>
+          <a:noFill/>
           <a:ln w="19050">
             <a:solidFill>
               <a:srgbClr val="D4D0C8"/>

</xml_diff>